<commit_message>
chore: using AI to draw dashboard
</commit_message>
<xml_diff>
--- a/KQKD_Thang6_2026.pptx
+++ b/KQKD_Thang6_2026.pptx
@@ -4,6 +4,9 @@
   <p:sldMasterIdLst>
     <p:sldMasterId id="2147483648" r:id="rId1"/>
   </p:sldMasterIdLst>
+  <p:notesMasterIdLst>
+    <p:notesMasterId r:id="rId10"/>
+  </p:notesMasterIdLst>
   <p:sldIdLst>
     <p:sldId id="256" r:id="rId2"/>
     <p:sldId id="257" r:id="rId3"/>
@@ -14,9 +17,6 @@
     <p:sldId id="262" r:id="rId8"/>
     <p:sldId id="263" r:id="rId9"/>
   </p:sldIdLst>
-  <p:notesMasterIdLst>
-    <p:notesMasterId r:id="rId10"/>
-  </p:notesMasterIdLst>
   <p:sldSz cx="12192000" cy="6858000"/>
   <p:notesSz cx="6858000" cy="12192000"/>
   <p:defaultTextStyle>
@@ -111,13 +111,20 @@
       </a:defRPr>
     </a:lvl9pPr>
   </p:defaultTextStyle>
+  <p:extLst>
+    <p:ext uri="{EFAFB233-063F-42B5-8137-9DF3F51BA10A}">
+      <p15:sldGuideLst xmlns:p15="http://schemas.microsoft.com/office/powerpoint/2012/main"/>
+    </p:ext>
+  </p:extLst>
 </p:presentation>
 </file>
 
 <file path=ppt/charts/chart1.xml><?xml version="1.0" encoding="utf-8"?>
-<c:chartSpace xmlns:c="http://schemas.openxmlformats.org/drawingml/2006/chart" xmlns:a="http://schemas.openxmlformats.org/drawingml/2006/main" xmlns:r="http://schemas.openxmlformats.org/officeDocument/2006/relationships">
+<c:chartSpace xmlns:c="http://schemas.openxmlformats.org/drawingml/2006/chart" xmlns:a="http://schemas.openxmlformats.org/drawingml/2006/main" xmlns:r="http://schemas.openxmlformats.org/officeDocument/2006/relationships" xmlns:c16r2="http://schemas.microsoft.com/office/drawing/2015/06/chart">
   <c:date1904 val="0"/>
+  <c:lang val="en-US"/>
   <c:roundedCorners val="1"/>
+  <c:style val="2"/>
   <c:chart>
     <c:title>
       <c:tx>
@@ -134,7 +141,7 @@
               </a:defRPr>
             </a:pPr>
             <a:r>
-              <a:rPr sz="1300" b="0" i="0" u="none" strike="noStrike">
+              <a:rPr lang="vi-VN" sz="1300" b="0" i="0" u="none" strike="noStrike">
                 <a:solidFill>
                   <a:srgbClr val="1E2761"/>
                 </a:solidFill>
@@ -145,7 +152,6 @@
           </a:p>
         </c:rich>
       </c:tx>
-      <c:layout/>
       <c:overlay val="0"/>
     </c:title>
     <c:autoTitleDeleted val="0"/>
@@ -176,30 +182,6 @@
             <a:effectLst/>
           </c:spPr>
           <c:invertIfNegative val="0"/>
-          <c:dLbls>
-            <c:numFmt formatCode="#,##0" sourceLinked="0"/>
-            <c:txPr>
-              <a:bodyPr/>
-              <a:lstStyle/>
-              <a:p>
-                <a:pPr>
-                  <a:defRPr b="0" i="0" strike="noStrike" sz="900" u="none">
-                    <a:solidFill>
-                      <a:srgbClr val="44506B"/>
-                    </a:solidFill>
-                    <a:latin typeface="Calibri"/>
-                  </a:defRPr>
-                </a:pPr>
-              </a:p>
-            </c:txPr>
-            <c:showLegendKey val="0"/>
-            <c:showVal val="1"/>
-            <c:showCatName val="0"/>
-            <c:showSerName val="0"/>
-            <c:showPercent val="0"/>
-            <c:showBubbleSize val="0"/>
-            <c:showLeaderLines val="0"/>
-          </c:dLbls>
           <c:dPt>
             <c:idx val="0"/>
             <c:invertIfNegative val="0"/>
@@ -210,6 +192,11 @@
               </a:solidFill>
               <a:effectLst/>
             </c:spPr>
+            <c:extLst>
+              <c:ext xmlns:c16="http://schemas.microsoft.com/office/drawing/2014/chart" uri="{C3380CC4-5D6E-409C-BE32-E72D297353CC}">
+                <c16:uniqueId val="{00000001-AB11-40DF-837C-B7DC1EDCDED7}"/>
+              </c:ext>
+            </c:extLst>
           </c:dPt>
           <c:dPt>
             <c:idx val="1"/>
@@ -221,6 +208,11 @@
               </a:solidFill>
               <a:effectLst/>
             </c:spPr>
+            <c:extLst>
+              <c:ext xmlns:c16="http://schemas.microsoft.com/office/drawing/2014/chart" uri="{C3380CC4-5D6E-409C-BE32-E72D297353CC}">
+                <c16:uniqueId val="{00000003-AB11-40DF-837C-B7DC1EDCDED7}"/>
+              </c:ext>
+            </c:extLst>
           </c:dPt>
           <c:dPt>
             <c:idx val="2"/>
@@ -232,6 +224,11 @@
               </a:solidFill>
               <a:effectLst/>
             </c:spPr>
+            <c:extLst>
+              <c:ext xmlns:c16="http://schemas.microsoft.com/office/drawing/2014/chart" uri="{C3380CC4-5D6E-409C-BE32-E72D297353CC}">
+                <c16:uniqueId val="{00000005-AB11-40DF-837C-B7DC1EDCDED7}"/>
+              </c:ext>
+            </c:extLst>
           </c:dPt>
           <c:dPt>
             <c:idx val="3"/>
@@ -243,6 +240,11 @@
               </a:solidFill>
               <a:effectLst/>
             </c:spPr>
+            <c:extLst>
+              <c:ext xmlns:c16="http://schemas.microsoft.com/office/drawing/2014/chart" uri="{C3380CC4-5D6E-409C-BE32-E72D297353CC}">
+                <c16:uniqueId val="{00000007-AB11-40DF-837C-B7DC1EDCDED7}"/>
+              </c:ext>
+            </c:extLst>
           </c:dPt>
           <c:dPt>
             <c:idx val="4"/>
@@ -254,6 +256,11 @@
               </a:solidFill>
               <a:effectLst/>
             </c:spPr>
+            <c:extLst>
+              <c:ext xmlns:c16="http://schemas.microsoft.com/office/drawing/2014/chart" uri="{C3380CC4-5D6E-409C-BE32-E72D297353CC}">
+                <c16:uniqueId val="{00000009-AB11-40DF-837C-B7DC1EDCDED7}"/>
+              </c:ext>
+            </c:extLst>
           </c:dPt>
           <c:dPt>
             <c:idx val="5"/>
@@ -265,34 +272,74 @@
               </a:solidFill>
               <a:effectLst/>
             </c:spPr>
+            <c:extLst>
+              <c:ext xmlns:c16="http://schemas.microsoft.com/office/drawing/2014/chart" uri="{C3380CC4-5D6E-409C-BE32-E72D297353CC}">
+                <c16:uniqueId val="{0000000B-AB11-40DF-837C-B7DC1EDCDED7}"/>
+              </c:ext>
+            </c:extLst>
           </c:dPt>
+          <c:dLbls>
+            <c:numFmt formatCode="#,##0" sourceLinked="0"/>
+            <c:spPr>
+              <a:noFill/>
+              <a:ln>
+                <a:noFill/>
+              </a:ln>
+              <a:effectLst/>
+            </c:spPr>
+            <c:txPr>
+              <a:bodyPr/>
+              <a:lstStyle/>
+              <a:p>
+                <a:pPr>
+                  <a:defRPr sz="900" b="0" i="0" u="none" strike="noStrike">
+                    <a:solidFill>
+                      <a:srgbClr val="44506B"/>
+                    </a:solidFill>
+                    <a:latin typeface="Calibri"/>
+                  </a:defRPr>
+                </a:pPr>
+                <a:endParaRPr lang="vi-VN"/>
+              </a:p>
+            </c:txPr>
+            <c:showLegendKey val="0"/>
+            <c:showVal val="1"/>
+            <c:showCatName val="0"/>
+            <c:showSerName val="0"/>
+            <c:showPercent val="0"/>
+            <c:showBubbleSize val="0"/>
+            <c:showLeaderLines val="0"/>
+            <c:extLst>
+              <c:ext xmlns:c15="http://schemas.microsoft.com/office/drawing/2012/chart" uri="{CE6537A1-D6FC-4f65-9D91-7224C49458BB}">
+                <c15:showLeaderLines val="0"/>
+              </c:ext>
+            </c:extLst>
+          </c:dLbls>
           <c:cat>
-            <c:multiLvlStrRef>
+            <c:strRef>
               <c:f>Sheet1!$A$2:$A$7</c:f>
-              <c:multiLvlStrCache>
+              <c:strCache>
                 <c:ptCount val="6"/>
-                <c:lvl>
-                  <c:pt idx="0">
-                    <c:v>T1</c:v>
-                  </c:pt>
-                  <c:pt idx="1">
-                    <c:v>T2</c:v>
-                  </c:pt>
-                  <c:pt idx="2">
-                    <c:v>T3</c:v>
-                  </c:pt>
-                  <c:pt idx="3">
-                    <c:v>T4</c:v>
-                  </c:pt>
-                  <c:pt idx="4">
-                    <c:v>T5</c:v>
-                  </c:pt>
-                  <c:pt idx="5">
-                    <c:v>T6</c:v>
-                  </c:pt>
-                </c:lvl>
-              </c:multiLvlStrCache>
-            </c:multiLvlStrRef>
+                <c:pt idx="0">
+                  <c:v>T1</c:v>
+                </c:pt>
+                <c:pt idx="1">
+                  <c:v>T2</c:v>
+                </c:pt>
+                <c:pt idx="2">
+                  <c:v>T3</c:v>
+                </c:pt>
+                <c:pt idx="3">
+                  <c:v>T4</c:v>
+                </c:pt>
+                <c:pt idx="4">
+                  <c:v>T5</c:v>
+                </c:pt>
+                <c:pt idx="5">
+                  <c:v>T6</c:v>
+                </c:pt>
+              </c:strCache>
+            </c:strRef>
           </c:cat>
           <c:val>
             <c:numRef>
@@ -321,36 +368,23 @@
               </c:numCache>
             </c:numRef>
           </c:val>
+          <c:extLst>
+            <c:ext xmlns:c16="http://schemas.microsoft.com/office/drawing/2014/chart" uri="{C3380CC4-5D6E-409C-BE32-E72D297353CC}">
+              <c16:uniqueId val="{0000000C-AB11-40DF-837C-B7DC1EDCDED7}"/>
+            </c:ext>
+          </c:extLst>
         </c:ser>
         <c:dLbls>
-          <c:numFmt formatCode="#,##0" sourceLinked="0"/>
-          <c:txPr>
-            <a:bodyPr/>
-            <a:lstStyle/>
-            <a:p>
-              <a:pPr>
-                <a:defRPr b="0" i="0" strike="noStrike" sz="900" u="none">
-                  <a:solidFill>
-                    <a:srgbClr val="44506B"/>
-                  </a:solidFill>
-                  <a:latin typeface="Calibri"/>
-                </a:defRPr>
-              </a:pPr>
-            </a:p>
-          </c:txPr>
           <c:showLegendKey val="0"/>
           <c:showVal val="1"/>
           <c:showCatName val="0"/>
           <c:showSerName val="0"/>
           <c:showPercent val="0"/>
           <c:showBubbleSize val="0"/>
-          <c:showLeaderLines val="0"/>
         </c:dLbls>
         <c:gapWidth val="45"/>
-        <c:overlap val="0"/>
         <c:axId val="2094734554"/>
         <c:axId val="2094734552"/>
-        <c:axId val="2094734556"/>
       </c:barChart>
       <c:catAx>
         <c:axId val="2094734554"/>
@@ -391,6 +425,7 @@
         <c:crosses val="autoZero"/>
         <c:auto val="1"/>
         <c:lblAlgn val="ctr"/>
+        <c:lblOffset val="100"/>
         <c:noMultiLvlLbl val="1"/>
       </c:catAx>
       <c:valAx>
@@ -455,6 +490,7 @@
     </c:plotArea>
     <c:plotVisOnly val="1"/>
     <c:dispBlanksAs val="span"/>
+    <c:showDLblsOverMax val="1"/>
   </c:chart>
   <c:spPr>
     <a:noFill/>
@@ -470,9 +506,11 @@
 </file>
 
 <file path=ppt/charts/chart2.xml><?xml version="1.0" encoding="utf-8"?>
-<c:chartSpace xmlns:c="http://schemas.openxmlformats.org/drawingml/2006/chart" xmlns:a="http://schemas.openxmlformats.org/drawingml/2006/main" xmlns:r="http://schemas.openxmlformats.org/officeDocument/2006/relationships">
+<c:chartSpace xmlns:c="http://schemas.openxmlformats.org/drawingml/2006/chart" xmlns:a="http://schemas.openxmlformats.org/drawingml/2006/main" xmlns:r="http://schemas.openxmlformats.org/officeDocument/2006/relationships" xmlns:c16r2="http://schemas.microsoft.com/office/drawing/2015/06/chart">
   <c:date1904 val="0"/>
+  <c:lang val="en-US"/>
   <c:roundedCorners val="1"/>
+  <c:style val="2"/>
   <c:chart>
     <c:title>
       <c:tx>
@@ -489,7 +527,7 @@
               </a:defRPr>
             </a:pPr>
             <a:r>
-              <a:rPr sz="1300" b="0" i="0" u="none" strike="noStrike">
+              <a:rPr lang="vi-VN" sz="1300" b="0" i="0" u="none" strike="noStrike">
                 <a:solidFill>
                   <a:srgbClr val="1E2761"/>
                 </a:solidFill>
@@ -500,7 +538,6 @@
           </a:p>
         </c:rich>
       </c:tx>
-      <c:layout/>
       <c:overlay val="0"/>
     </c:title>
     <c:autoTitleDeleted val="0"/>
@@ -533,18 +570,26 @@
           <c:invertIfNegative val="0"/>
           <c:dLbls>
             <c:numFmt formatCode="#,##0" sourceLinked="0"/>
+            <c:spPr>
+              <a:noFill/>
+              <a:ln>
+                <a:noFill/>
+              </a:ln>
+              <a:effectLst/>
+            </c:spPr>
             <c:txPr>
               <a:bodyPr/>
               <a:lstStyle/>
               <a:p>
                 <a:pPr>
-                  <a:defRPr b="0" i="0" strike="noStrike" sz="900" u="none">
+                  <a:defRPr sz="900" b="0" i="0" u="none" strike="noStrike">
                     <a:solidFill>
                       <a:srgbClr val="44506B"/>
                     </a:solidFill>
                     <a:latin typeface="Calibri"/>
                   </a:defRPr>
                 </a:pPr>
+                <a:endParaRPr lang="vi-VN"/>
               </a:p>
             </c:txPr>
             <c:showLegendKey val="0"/>
@@ -554,31 +599,34 @@
             <c:showPercent val="0"/>
             <c:showBubbleSize val="0"/>
             <c:showLeaderLines val="0"/>
+            <c:extLst>
+              <c:ext xmlns:c15="http://schemas.microsoft.com/office/drawing/2012/chart" uri="{CE6537A1-D6FC-4f65-9D91-7224C49458BB}">
+                <c15:showLeaderLines val="0"/>
+              </c:ext>
+            </c:extLst>
           </c:dLbls>
           <c:cat>
-            <c:multiLvlStrRef>
+            <c:strRef>
               <c:f>Sheet1!$A$2:$A$6</c:f>
-              <c:multiLvlStrCache>
+              <c:strCache>
                 <c:ptCount val="5"/>
-                <c:lvl>
-                  <c:pt idx="0">
-                    <c:v>Khách giới thiệu</c:v>
-                  </c:pt>
-                  <c:pt idx="1">
-                    <c:v>Sự kiện mở bán</c:v>
-                  </c:pt>
-                  <c:pt idx="2">
-                    <c:v>Online / Digital</c:v>
-                  </c:pt>
-                  <c:pt idx="3">
-                    <c:v>Đại lý F2</c:v>
-                  </c:pt>
-                  <c:pt idx="4">
-                    <c:v>Sàn nội bộ (F1)</c:v>
-                  </c:pt>
-                </c:lvl>
-              </c:multiLvlStrCache>
-            </c:multiLvlStrRef>
+                <c:pt idx="0">
+                  <c:v>Khách giới thiệu</c:v>
+                </c:pt>
+                <c:pt idx="1">
+                  <c:v>Sự kiện mở bán</c:v>
+                </c:pt>
+                <c:pt idx="2">
+                  <c:v>Online / Digital</c:v>
+                </c:pt>
+                <c:pt idx="3">
+                  <c:v>Đại lý F2</c:v>
+                </c:pt>
+                <c:pt idx="4">
+                  <c:v>Sàn nội bộ (F1)</c:v>
+                </c:pt>
+              </c:strCache>
+            </c:strRef>
           </c:cat>
           <c:val>
             <c:numRef>
@@ -596,7 +644,7 @@
                   <c:v>69.5</c:v>
                 </c:pt>
                 <c:pt idx="3">
-                  <c:v>132.3</c:v>
+                  <c:v>132.30000000000001</c:v>
                 </c:pt>
                 <c:pt idx="4">
                   <c:v>239.1</c:v>
@@ -604,6 +652,11 @@
               </c:numCache>
             </c:numRef>
           </c:val>
+          <c:extLst>
+            <c:ext xmlns:c16="http://schemas.microsoft.com/office/drawing/2014/chart" uri="{C3380CC4-5D6E-409C-BE32-E72D297353CC}">
+              <c16:uniqueId val="{00000000-6F94-4CA6-9B80-A075ECFE0627}"/>
+            </c:ext>
+          </c:extLst>
         </c:ser>
         <c:ser>
           <c:idx val="1"/>
@@ -628,18 +681,26 @@
           <c:invertIfNegative val="0"/>
           <c:dLbls>
             <c:numFmt formatCode="#,##0" sourceLinked="0"/>
+            <c:spPr>
+              <a:noFill/>
+              <a:ln>
+                <a:noFill/>
+              </a:ln>
+              <a:effectLst/>
+            </c:spPr>
             <c:txPr>
               <a:bodyPr/>
               <a:lstStyle/>
               <a:p>
                 <a:pPr>
-                  <a:defRPr b="0" i="0" strike="noStrike" sz="900" u="none">
+                  <a:defRPr sz="900" b="0" i="0" u="none" strike="noStrike">
                     <a:solidFill>
                       <a:srgbClr val="44506B"/>
                     </a:solidFill>
                     <a:latin typeface="Calibri"/>
                   </a:defRPr>
                 </a:pPr>
+                <a:endParaRPr lang="vi-VN"/>
               </a:p>
             </c:txPr>
             <c:showLegendKey val="0"/>
@@ -649,31 +710,34 @@
             <c:showPercent val="0"/>
             <c:showBubbleSize val="0"/>
             <c:showLeaderLines val="0"/>
+            <c:extLst>
+              <c:ext xmlns:c15="http://schemas.microsoft.com/office/drawing/2012/chart" uri="{CE6537A1-D6FC-4f65-9D91-7224C49458BB}">
+                <c15:showLeaderLines val="0"/>
+              </c:ext>
+            </c:extLst>
           </c:dLbls>
           <c:cat>
-            <c:multiLvlStrRef>
+            <c:strRef>
               <c:f>Sheet1!$A$2:$A$6</c:f>
-              <c:multiLvlStrCache>
+              <c:strCache>
                 <c:ptCount val="5"/>
-                <c:lvl>
-                  <c:pt idx="0">
-                    <c:v>Khách giới thiệu</c:v>
-                  </c:pt>
-                  <c:pt idx="1">
-                    <c:v>Sự kiện mở bán</c:v>
-                  </c:pt>
-                  <c:pt idx="2">
-                    <c:v>Online / Digital</c:v>
-                  </c:pt>
-                  <c:pt idx="3">
-                    <c:v>Đại lý F2</c:v>
-                  </c:pt>
-                  <c:pt idx="4">
-                    <c:v>Sàn nội bộ (F1)</c:v>
-                  </c:pt>
-                </c:lvl>
-              </c:multiLvlStrCache>
-            </c:multiLvlStrRef>
+                <c:pt idx="0">
+                  <c:v>Khách giới thiệu</c:v>
+                </c:pt>
+                <c:pt idx="1">
+                  <c:v>Sự kiện mở bán</c:v>
+                </c:pt>
+                <c:pt idx="2">
+                  <c:v>Online / Digital</c:v>
+                </c:pt>
+                <c:pt idx="3">
+                  <c:v>Đại lý F2</c:v>
+                </c:pt>
+                <c:pt idx="4">
+                  <c:v>Sàn nội bộ (F1)</c:v>
+                </c:pt>
+              </c:strCache>
+            </c:strRef>
           </c:cat>
           <c:val>
             <c:numRef>
@@ -685,7 +749,7 @@
                   <c:v>65.5</c:v>
                 </c:pt>
                 <c:pt idx="1">
-                  <c:v>78.1</c:v>
+                  <c:v>78.099999999999994</c:v>
                 </c:pt>
                 <c:pt idx="2">
                   <c:v>111.6</c:v>
@@ -694,41 +758,28 @@
                   <c:v>154.6</c:v>
                 </c:pt>
                 <c:pt idx="4">
-                  <c:v>258.9</c:v>
+                  <c:v>258.89999999999998</c:v>
                 </c:pt>
               </c:numCache>
             </c:numRef>
           </c:val>
+          <c:extLst>
+            <c:ext xmlns:c16="http://schemas.microsoft.com/office/drawing/2014/chart" uri="{C3380CC4-5D6E-409C-BE32-E72D297353CC}">
+              <c16:uniqueId val="{00000001-6F94-4CA6-9B80-A075ECFE0627}"/>
+            </c:ext>
+          </c:extLst>
         </c:ser>
         <c:dLbls>
-          <c:numFmt formatCode="#,##0" sourceLinked="0"/>
-          <c:txPr>
-            <a:bodyPr/>
-            <a:lstStyle/>
-            <a:p>
-              <a:pPr>
-                <a:defRPr b="0" i="0" strike="noStrike" sz="900" u="none">
-                  <a:solidFill>
-                    <a:srgbClr val="44506B"/>
-                  </a:solidFill>
-                  <a:latin typeface="Calibri"/>
-                </a:defRPr>
-              </a:pPr>
-            </a:p>
-          </c:txPr>
           <c:showLegendKey val="0"/>
           <c:showVal val="1"/>
           <c:showCatName val="0"/>
           <c:showSerName val="0"/>
           <c:showPercent val="0"/>
           <c:showBubbleSize val="0"/>
-          <c:showLeaderLines val="0"/>
         </c:dLbls>
         <c:gapWidth val="40"/>
-        <c:overlap val="0"/>
         <c:axId val="2094734554"/>
         <c:axId val="2094734552"/>
-        <c:axId val="2094734556"/>
       </c:barChart>
       <c:catAx>
         <c:axId val="2094734554"/>
@@ -769,6 +820,7 @@
         <c:crosses val="autoZero"/>
         <c:auto val="1"/>
         <c:lblAlgn val="ctr"/>
+        <c:lblOffset val="100"/>
         <c:noMultiLvlLbl val="1"/>
       </c:catAx>
       <c:valAx>
@@ -853,6 +905,7 @@
     </c:legend>
     <c:plotVisOnly val="1"/>
     <c:dispBlanksAs val="span"/>
+    <c:showDLblsOverMax val="1"/>
   </c:chart>
   <c:spPr>
     <a:noFill/>
@@ -868,9 +921,11 @@
 </file>
 
 <file path=ppt/charts/chart3.xml><?xml version="1.0" encoding="utf-8"?>
-<c:chartSpace xmlns:c="http://schemas.openxmlformats.org/drawingml/2006/chart" xmlns:a="http://schemas.openxmlformats.org/drawingml/2006/main" xmlns:r="http://schemas.openxmlformats.org/officeDocument/2006/relationships">
+<c:chartSpace xmlns:c="http://schemas.openxmlformats.org/drawingml/2006/chart" xmlns:a="http://schemas.openxmlformats.org/drawingml/2006/main" xmlns:r="http://schemas.openxmlformats.org/officeDocument/2006/relationships" xmlns:c16r2="http://schemas.microsoft.com/office/drawing/2015/06/chart">
   <c:date1904 val="0"/>
+  <c:lang val="en-US"/>
   <c:roundedCorners val="1"/>
+  <c:style val="2"/>
   <c:chart>
     <c:title>
       <c:tx>
@@ -887,7 +942,7 @@
               </a:defRPr>
             </a:pPr>
             <a:r>
-              <a:rPr sz="1300" b="0" i="0" u="none" strike="noStrike">
+              <a:rPr lang="vi-VN" sz="1300" b="0" i="0" u="none" strike="noStrike">
                 <a:solidFill>
                   <a:srgbClr val="1E2761"/>
                 </a:solidFill>
@@ -898,7 +953,6 @@
           </a:p>
         </c:rich>
       </c:tx>
-      <c:layout/>
       <c:overlay val="0"/>
     </c:title>
     <c:autoTitleDeleted val="0"/>
@@ -931,18 +985,26 @@
           <c:invertIfNegative val="0"/>
           <c:dLbls>
             <c:numFmt formatCode="#,##0" sourceLinked="0"/>
+            <c:spPr>
+              <a:noFill/>
+              <a:ln>
+                <a:noFill/>
+              </a:ln>
+              <a:effectLst/>
+            </c:spPr>
             <c:txPr>
               <a:bodyPr/>
               <a:lstStyle/>
               <a:p>
                 <a:pPr>
-                  <a:defRPr b="0" i="0" strike="noStrike" sz="900" u="none">
+                  <a:defRPr sz="900" b="0" i="0" u="none" strike="noStrike">
                     <a:solidFill>
                       <a:srgbClr val="44506B"/>
                     </a:solidFill>
                     <a:latin typeface="Calibri"/>
                   </a:defRPr>
                 </a:pPr>
+                <a:endParaRPr lang="vi-VN"/>
               </a:p>
             </c:txPr>
             <c:showLegendKey val="0"/>
@@ -952,34 +1014,37 @@
             <c:showPercent val="0"/>
             <c:showBubbleSize val="0"/>
             <c:showLeaderLines val="0"/>
+            <c:extLst>
+              <c:ext xmlns:c15="http://schemas.microsoft.com/office/drawing/2012/chart" uri="{CE6537A1-D6FC-4f65-9D91-7224C49458BB}">
+                <c15:showLeaderLines val="0"/>
+              </c:ext>
+            </c:extLst>
           </c:dLbls>
           <c:cat>
-            <c:multiLvlStrRef>
+            <c:strRef>
               <c:f>Sheet1!$A$2:$A$7</c:f>
-              <c:multiLvlStrCache>
+              <c:strCache>
                 <c:ptCount val="6"/>
-                <c:lvl>
-                  <c:pt idx="0">
-                    <c:v>Condotel</c:v>
-                  </c:pt>
-                  <c:pt idx="1">
-                    <c:v>Shophouse</c:v>
-                  </c:pt>
-                  <c:pt idx="2">
-                    <c:v>Căn hộ chung cư</c:v>
-                  </c:pt>
-                  <c:pt idx="3">
-                    <c:v>Đất nền</c:v>
-                  </c:pt>
-                  <c:pt idx="4">
-                    <c:v>Nhà phố / Liền kề</c:v>
-                  </c:pt>
-                  <c:pt idx="5">
-                    <c:v>Biệt thự</c:v>
-                  </c:pt>
-                </c:lvl>
-              </c:multiLvlStrCache>
-            </c:multiLvlStrRef>
+                <c:pt idx="0">
+                  <c:v>Condotel</c:v>
+                </c:pt>
+                <c:pt idx="1">
+                  <c:v>Shophouse</c:v>
+                </c:pt>
+                <c:pt idx="2">
+                  <c:v>Căn hộ chung cư</c:v>
+                </c:pt>
+                <c:pt idx="3">
+                  <c:v>Đất nền</c:v>
+                </c:pt>
+                <c:pt idx="4">
+                  <c:v>Nhà phố / Liền kề</c:v>
+                </c:pt>
+                <c:pt idx="5">
+                  <c:v>Biệt thự</c:v>
+                </c:pt>
+              </c:strCache>
+            </c:strRef>
           </c:cat>
           <c:val>
             <c:numRef>
@@ -1000,7 +1065,7 @@
                   <c:v>61.8</c:v>
                 </c:pt>
                 <c:pt idx="4">
-                  <c:v>129.3</c:v>
+                  <c:v>129.30000000000001</c:v>
                 </c:pt>
                 <c:pt idx="5">
                   <c:v>104.2</c:v>
@@ -1008,6 +1073,11 @@
               </c:numCache>
             </c:numRef>
           </c:val>
+          <c:extLst>
+            <c:ext xmlns:c16="http://schemas.microsoft.com/office/drawing/2014/chart" uri="{C3380CC4-5D6E-409C-BE32-E72D297353CC}">
+              <c16:uniqueId val="{00000000-186B-4241-827E-69354AE68558}"/>
+            </c:ext>
+          </c:extLst>
         </c:ser>
         <c:ser>
           <c:idx val="1"/>
@@ -1032,18 +1102,26 @@
           <c:invertIfNegative val="0"/>
           <c:dLbls>
             <c:numFmt formatCode="#,##0" sourceLinked="0"/>
+            <c:spPr>
+              <a:noFill/>
+              <a:ln>
+                <a:noFill/>
+              </a:ln>
+              <a:effectLst/>
+            </c:spPr>
             <c:txPr>
               <a:bodyPr/>
               <a:lstStyle/>
               <a:p>
                 <a:pPr>
-                  <a:defRPr b="0" i="0" strike="noStrike" sz="900" u="none">
+                  <a:defRPr sz="900" b="0" i="0" u="none" strike="noStrike">
                     <a:solidFill>
                       <a:srgbClr val="44506B"/>
                     </a:solidFill>
                     <a:latin typeface="Calibri"/>
                   </a:defRPr>
                 </a:pPr>
+                <a:endParaRPr lang="vi-VN"/>
               </a:p>
             </c:txPr>
             <c:showLegendKey val="0"/>
@@ -1053,34 +1131,37 @@
             <c:showPercent val="0"/>
             <c:showBubbleSize val="0"/>
             <c:showLeaderLines val="0"/>
+            <c:extLst>
+              <c:ext xmlns:c15="http://schemas.microsoft.com/office/drawing/2012/chart" uri="{CE6537A1-D6FC-4f65-9D91-7224C49458BB}">
+                <c15:showLeaderLines val="0"/>
+              </c:ext>
+            </c:extLst>
           </c:dLbls>
           <c:cat>
-            <c:multiLvlStrRef>
+            <c:strRef>
               <c:f>Sheet1!$A$2:$A$7</c:f>
-              <c:multiLvlStrCache>
+              <c:strCache>
                 <c:ptCount val="6"/>
-                <c:lvl>
-                  <c:pt idx="0">
-                    <c:v>Condotel</c:v>
-                  </c:pt>
-                  <c:pt idx="1">
-                    <c:v>Shophouse</c:v>
-                  </c:pt>
-                  <c:pt idx="2">
-                    <c:v>Căn hộ chung cư</c:v>
-                  </c:pt>
-                  <c:pt idx="3">
-                    <c:v>Đất nền</c:v>
-                  </c:pt>
-                  <c:pt idx="4">
-                    <c:v>Nhà phố / Liền kề</c:v>
-                  </c:pt>
-                  <c:pt idx="5">
-                    <c:v>Biệt thự</c:v>
-                  </c:pt>
-                </c:lvl>
-              </c:multiLvlStrCache>
-            </c:multiLvlStrRef>
+                <c:pt idx="0">
+                  <c:v>Condotel</c:v>
+                </c:pt>
+                <c:pt idx="1">
+                  <c:v>Shophouse</c:v>
+                </c:pt>
+                <c:pt idx="2">
+                  <c:v>Căn hộ chung cư</c:v>
+                </c:pt>
+                <c:pt idx="3">
+                  <c:v>Đất nền</c:v>
+                </c:pt>
+                <c:pt idx="4">
+                  <c:v>Nhà phố / Liền kề</c:v>
+                </c:pt>
+                <c:pt idx="5">
+                  <c:v>Biệt thự</c:v>
+                </c:pt>
+              </c:strCache>
+            </c:strRef>
           </c:cat>
           <c:val>
             <c:numRef>
@@ -1109,36 +1190,23 @@
               </c:numCache>
             </c:numRef>
           </c:val>
+          <c:extLst>
+            <c:ext xmlns:c16="http://schemas.microsoft.com/office/drawing/2014/chart" uri="{C3380CC4-5D6E-409C-BE32-E72D297353CC}">
+              <c16:uniqueId val="{00000001-186B-4241-827E-69354AE68558}"/>
+            </c:ext>
+          </c:extLst>
         </c:ser>
         <c:dLbls>
-          <c:numFmt formatCode="#,##0" sourceLinked="0"/>
-          <c:txPr>
-            <a:bodyPr/>
-            <a:lstStyle/>
-            <a:p>
-              <a:pPr>
-                <a:defRPr b="0" i="0" strike="noStrike" sz="900" u="none">
-                  <a:solidFill>
-                    <a:srgbClr val="44506B"/>
-                  </a:solidFill>
-                  <a:latin typeface="Calibri"/>
-                </a:defRPr>
-              </a:pPr>
-            </a:p>
-          </c:txPr>
           <c:showLegendKey val="0"/>
           <c:showVal val="1"/>
           <c:showCatName val="0"/>
           <c:showSerName val="0"/>
           <c:showPercent val="0"/>
           <c:showBubbleSize val="0"/>
-          <c:showLeaderLines val="0"/>
         </c:dLbls>
         <c:gapWidth val="40"/>
-        <c:overlap val="0"/>
         <c:axId val="2094734554"/>
         <c:axId val="2094734552"/>
-        <c:axId val="2094734556"/>
       </c:barChart>
       <c:catAx>
         <c:axId val="2094734554"/>
@@ -1179,6 +1247,7 @@
         <c:crosses val="autoZero"/>
         <c:auto val="1"/>
         <c:lblAlgn val="ctr"/>
+        <c:lblOffset val="100"/>
         <c:noMultiLvlLbl val="1"/>
       </c:catAx>
       <c:valAx>
@@ -1263,6 +1332,7 @@
     </c:legend>
     <c:plotVisOnly val="1"/>
     <c:dispBlanksAs val="span"/>
+    <c:showDLblsOverMax val="1"/>
   </c:chart>
   <c:spPr>
     <a:noFill/>
@@ -1278,9 +1348,11 @@
 </file>
 
 <file path=ppt/charts/chart4.xml><?xml version="1.0" encoding="utf-8"?>
-<c:chartSpace xmlns:c="http://schemas.openxmlformats.org/drawingml/2006/chart" xmlns:a="http://schemas.openxmlformats.org/drawingml/2006/main" xmlns:r="http://schemas.openxmlformats.org/officeDocument/2006/relationships">
+<c:chartSpace xmlns:c="http://schemas.openxmlformats.org/drawingml/2006/chart" xmlns:a="http://schemas.openxmlformats.org/drawingml/2006/main" xmlns:r="http://schemas.openxmlformats.org/officeDocument/2006/relationships" xmlns:c16r2="http://schemas.microsoft.com/office/drawing/2015/06/chart">
   <c:date1904 val="0"/>
+  <c:lang val="en-US"/>
   <c:roundedCorners val="1"/>
+  <c:style val="2"/>
   <c:chart>
     <c:title>
       <c:tx>
@@ -1297,7 +1369,7 @@
               </a:defRPr>
             </a:pPr>
             <a:r>
-              <a:rPr sz="1300" b="0" i="0" u="none" strike="noStrike">
+              <a:rPr lang="vi-VN" sz="1300" b="0" i="0" u="none" strike="noStrike">
                 <a:solidFill>
                   <a:srgbClr val="1E2761"/>
                 </a:solidFill>
@@ -1308,7 +1380,6 @@
           </a:p>
         </c:rich>
       </c:tx>
-      <c:layout/>
       <c:overlay val="0"/>
     </c:title>
     <c:autoTitleDeleted val="0"/>
@@ -1341,18 +1412,26 @@
           <c:invertIfNegative val="0"/>
           <c:dLbls>
             <c:numFmt formatCode="#,##0" sourceLinked="0"/>
+            <c:spPr>
+              <a:noFill/>
+              <a:ln>
+                <a:noFill/>
+              </a:ln>
+              <a:effectLst/>
+            </c:spPr>
             <c:txPr>
               <a:bodyPr/>
               <a:lstStyle/>
               <a:p>
                 <a:pPr>
-                  <a:defRPr b="0" i="0" strike="noStrike" sz="1000" u="none">
+                  <a:defRPr sz="1000" b="0" i="0" u="none" strike="noStrike">
                     <a:solidFill>
                       <a:srgbClr val="FFFFFF"/>
                     </a:solidFill>
                     <a:latin typeface="Calibri"/>
                   </a:defRPr>
                 </a:pPr>
+                <a:endParaRPr lang="vi-VN"/>
               </a:p>
             </c:txPr>
             <c:dLblPos val="ctr"/>
@@ -1363,34 +1442,37 @@
             <c:showPercent val="0"/>
             <c:showBubbleSize val="0"/>
             <c:showLeaderLines val="0"/>
+            <c:extLst>
+              <c:ext xmlns:c15="http://schemas.microsoft.com/office/drawing/2012/chart" uri="{CE6537A1-D6FC-4f65-9D91-7224C49458BB}">
+                <c15:showLeaderLines val="0"/>
+              </c:ext>
+            </c:extLst>
           </c:dLbls>
           <c:cat>
-            <c:multiLvlStrRef>
+            <c:strRef>
               <c:f>Sheet1!$A$2:$A$7</c:f>
-              <c:multiLvlStrCache>
+              <c:strCache>
                 <c:ptCount val="6"/>
-                <c:lvl>
-                  <c:pt idx="0">
-                    <c:v>T1</c:v>
-                  </c:pt>
-                  <c:pt idx="1">
-                    <c:v>T2</c:v>
-                  </c:pt>
-                  <c:pt idx="2">
-                    <c:v>T3</c:v>
-                  </c:pt>
-                  <c:pt idx="3">
-                    <c:v>T4</c:v>
-                  </c:pt>
-                  <c:pt idx="4">
-                    <c:v>T5</c:v>
-                  </c:pt>
-                  <c:pt idx="5">
-                    <c:v>T6</c:v>
-                  </c:pt>
-                </c:lvl>
-              </c:multiLvlStrCache>
-            </c:multiLvlStrRef>
+                <c:pt idx="0">
+                  <c:v>T1</c:v>
+                </c:pt>
+                <c:pt idx="1">
+                  <c:v>T2</c:v>
+                </c:pt>
+                <c:pt idx="2">
+                  <c:v>T3</c:v>
+                </c:pt>
+                <c:pt idx="3">
+                  <c:v>T4</c:v>
+                </c:pt>
+                <c:pt idx="4">
+                  <c:v>T5</c:v>
+                </c:pt>
+                <c:pt idx="5">
+                  <c:v>T6</c:v>
+                </c:pt>
+              </c:strCache>
+            </c:strRef>
           </c:cat>
           <c:val>
             <c:numRef>
@@ -1405,7 +1487,7 @@
                   <c:v>230.5</c:v>
                 </c:pt>
                 <c:pt idx="2">
-                  <c:v>299.9</c:v>
+                  <c:v>299.89999999999998</c:v>
                 </c:pt>
                 <c:pt idx="3">
                   <c:v>446.1</c:v>
@@ -1419,6 +1501,11 @@
               </c:numCache>
             </c:numRef>
           </c:val>
+          <c:extLst>
+            <c:ext xmlns:c16="http://schemas.microsoft.com/office/drawing/2014/chart" uri="{C3380CC4-5D6E-409C-BE32-E72D297353CC}">
+              <c16:uniqueId val="{00000000-24D1-4B1F-96B7-72FBA76FFA5B}"/>
+            </c:ext>
+          </c:extLst>
         </c:ser>
         <c:ser>
           <c:idx val="1"/>
@@ -1443,18 +1530,26 @@
           <c:invertIfNegative val="0"/>
           <c:dLbls>
             <c:numFmt formatCode="#,##0" sourceLinked="0"/>
+            <c:spPr>
+              <a:noFill/>
+              <a:ln>
+                <a:noFill/>
+              </a:ln>
+              <a:effectLst/>
+            </c:spPr>
             <c:txPr>
               <a:bodyPr/>
               <a:lstStyle/>
               <a:p>
                 <a:pPr>
-                  <a:defRPr b="0" i="0" strike="noStrike" sz="1000" u="none">
+                  <a:defRPr sz="1000" b="0" i="0" u="none" strike="noStrike">
                     <a:solidFill>
                       <a:srgbClr val="FFFFFF"/>
                     </a:solidFill>
                     <a:latin typeface="Calibri"/>
                   </a:defRPr>
                 </a:pPr>
+                <a:endParaRPr lang="vi-VN"/>
               </a:p>
             </c:txPr>
             <c:dLblPos val="ctr"/>
@@ -1465,34 +1560,37 @@
             <c:showPercent val="0"/>
             <c:showBubbleSize val="0"/>
             <c:showLeaderLines val="0"/>
+            <c:extLst>
+              <c:ext xmlns:c15="http://schemas.microsoft.com/office/drawing/2012/chart" uri="{CE6537A1-D6FC-4f65-9D91-7224C49458BB}">
+                <c15:showLeaderLines val="0"/>
+              </c:ext>
+            </c:extLst>
           </c:dLbls>
           <c:cat>
-            <c:multiLvlStrRef>
+            <c:strRef>
               <c:f>Sheet1!$A$2:$A$7</c:f>
-              <c:multiLvlStrCache>
+              <c:strCache>
                 <c:ptCount val="6"/>
-                <c:lvl>
-                  <c:pt idx="0">
-                    <c:v>T1</c:v>
-                  </c:pt>
-                  <c:pt idx="1">
-                    <c:v>T2</c:v>
-                  </c:pt>
-                  <c:pt idx="2">
-                    <c:v>T3</c:v>
-                  </c:pt>
-                  <c:pt idx="3">
-                    <c:v>T4</c:v>
-                  </c:pt>
-                  <c:pt idx="4">
-                    <c:v>T5</c:v>
-                  </c:pt>
-                  <c:pt idx="5">
-                    <c:v>T6</c:v>
-                  </c:pt>
-                </c:lvl>
-              </c:multiLvlStrCache>
-            </c:multiLvlStrRef>
+                <c:pt idx="0">
+                  <c:v>T1</c:v>
+                </c:pt>
+                <c:pt idx="1">
+                  <c:v>T2</c:v>
+                </c:pt>
+                <c:pt idx="2">
+                  <c:v>T3</c:v>
+                </c:pt>
+                <c:pt idx="3">
+                  <c:v>T4</c:v>
+                </c:pt>
+                <c:pt idx="4">
+                  <c:v>T5</c:v>
+                </c:pt>
+                <c:pt idx="5">
+                  <c:v>T6</c:v>
+                </c:pt>
+              </c:strCache>
+            </c:strRef>
           </c:cat>
           <c:val>
             <c:numRef>
@@ -1504,7 +1602,7 @@
                   <c:v>115.2</c:v>
                 </c:pt>
                 <c:pt idx="1">
-                  <c:v>155.2</c:v>
+                  <c:v>155.19999999999999</c:v>
                 </c:pt>
                 <c:pt idx="2">
                   <c:v>239.2</c:v>
@@ -1521,23 +1619,13 @@
               </c:numCache>
             </c:numRef>
           </c:val>
+          <c:extLst>
+            <c:ext xmlns:c16="http://schemas.microsoft.com/office/drawing/2014/chart" uri="{C3380CC4-5D6E-409C-BE32-E72D297353CC}">
+              <c16:uniqueId val="{00000001-24D1-4B1F-96B7-72FBA76FFA5B}"/>
+            </c:ext>
+          </c:extLst>
         </c:ser>
         <c:dLbls>
-          <c:numFmt formatCode="#,##0" sourceLinked="0"/>
-          <c:txPr>
-            <a:bodyPr/>
-            <a:lstStyle/>
-            <a:p>
-              <a:pPr>
-                <a:defRPr b="0" i="0" strike="noStrike" sz="1000" u="none">
-                  <a:solidFill>
-                    <a:srgbClr val="FFFFFF"/>
-                  </a:solidFill>
-                  <a:latin typeface="Calibri"/>
-                </a:defRPr>
-              </a:pPr>
-            </a:p>
-          </c:txPr>
           <c:dLblPos val="ctr"/>
           <c:showLegendKey val="0"/>
           <c:showVal val="1"/>
@@ -1545,13 +1633,11 @@
           <c:showSerName val="0"/>
           <c:showPercent val="0"/>
           <c:showBubbleSize val="0"/>
-          <c:showLeaderLines val="0"/>
         </c:dLbls>
         <c:gapWidth val="55"/>
         <c:overlap val="100"/>
         <c:axId val="2094734554"/>
         <c:axId val="2094734552"/>
-        <c:axId val="2094734556"/>
       </c:barChart>
       <c:catAx>
         <c:axId val="2094734554"/>
@@ -1592,6 +1678,7 @@
         <c:crosses val="autoZero"/>
         <c:auto val="1"/>
         <c:lblAlgn val="ctr"/>
+        <c:lblOffset val="100"/>
         <c:noMultiLvlLbl val="1"/>
       </c:catAx>
       <c:valAx>
@@ -1676,6 +1763,7 @@
     </c:legend>
     <c:plotVisOnly val="1"/>
     <c:dispBlanksAs val="span"/>
+    <c:showDLblsOverMax val="1"/>
   </c:chart>
   <c:spPr>
     <a:noFill/>
@@ -1691,9 +1779,11 @@
 </file>
 
 <file path=ppt/charts/chart5.xml><?xml version="1.0" encoding="utf-8"?>
-<c:chartSpace xmlns:c="http://schemas.openxmlformats.org/drawingml/2006/chart" xmlns:a="http://schemas.openxmlformats.org/drawingml/2006/main" xmlns:r="http://schemas.openxmlformats.org/officeDocument/2006/relationships">
+<c:chartSpace xmlns:c="http://schemas.openxmlformats.org/drawingml/2006/chart" xmlns:a="http://schemas.openxmlformats.org/drawingml/2006/main" xmlns:r="http://schemas.openxmlformats.org/officeDocument/2006/relationships" xmlns:c16r2="http://schemas.microsoft.com/office/drawing/2015/06/chart">
   <c:date1904 val="0"/>
+  <c:lang val="en-US"/>
   <c:roundedCorners val="1"/>
+  <c:style val="2"/>
   <c:chart>
     <c:autoTitleDeleted val="1"/>
     <c:plotArea>
@@ -1725,18 +1815,26 @@
           <c:invertIfNegative val="0"/>
           <c:dLbls>
             <c:numFmt formatCode="#,##0" sourceLinked="0"/>
+            <c:spPr>
+              <a:noFill/>
+              <a:ln>
+                <a:noFill/>
+              </a:ln>
+              <a:effectLst/>
+            </c:spPr>
             <c:txPr>
               <a:bodyPr/>
               <a:lstStyle/>
               <a:p>
                 <a:pPr>
-                  <a:defRPr b="0" i="0" strike="noStrike" sz="900" u="none">
+                  <a:defRPr sz="900" b="0" i="0" u="none" strike="noStrike">
                     <a:solidFill>
                       <a:srgbClr val="44506B"/>
                     </a:solidFill>
                     <a:latin typeface="Calibri"/>
                   </a:defRPr>
                 </a:pPr>
+                <a:endParaRPr lang="vi-VN"/>
               </a:p>
             </c:txPr>
             <c:showLegendKey val="0"/>
@@ -1746,46 +1844,49 @@
             <c:showPercent val="0"/>
             <c:showBubbleSize val="0"/>
             <c:showLeaderLines val="0"/>
+            <c:extLst>
+              <c:ext xmlns:c15="http://schemas.microsoft.com/office/drawing/2012/chart" uri="{CE6537A1-D6FC-4f65-9D91-7224C49458BB}">
+                <c15:showLeaderLines val="0"/>
+              </c:ext>
+            </c:extLst>
           </c:dLbls>
           <c:cat>
-            <c:multiLvlStrRef>
+            <c:strRef>
               <c:f>Sheet1!$A$2:$A$11</c:f>
-              <c:multiLvlStrCache>
+              <c:strCache>
                 <c:ptCount val="10"/>
-                <c:lvl>
-                  <c:pt idx="0">
-                    <c:v>Đỗ Thanh Lam</c:v>
-                  </c:pt>
-                  <c:pt idx="1">
-                    <c:v>Trần Thị Bích</c:v>
-                  </c:pt>
-                  <c:pt idx="2">
-                    <c:v>Nguyễn Văn An</c:v>
-                  </c:pt>
-                  <c:pt idx="3">
-                    <c:v>Đặng Trung Kiên</c:v>
-                  </c:pt>
-                  <c:pt idx="4">
-                    <c:v>Phạm Quốc Dũng</c:v>
-                  </c:pt>
-                  <c:pt idx="5">
-                    <c:v>Lê Minh Châu</c:v>
-                  </c:pt>
-                  <c:pt idx="6">
-                    <c:v>Ngô Phương Oanh</c:v>
-                  </c:pt>
-                  <c:pt idx="7">
-                    <c:v>Vũ Đình Hùng</c:v>
-                  </c:pt>
-                  <c:pt idx="8">
-                    <c:v>Hoàng Thị Giang</c:v>
-                  </c:pt>
-                  <c:pt idx="9">
-                    <c:v>Bùi Hải Nam</c:v>
-                  </c:pt>
-                </c:lvl>
-              </c:multiLvlStrCache>
-            </c:multiLvlStrRef>
+                <c:pt idx="0">
+                  <c:v>Đỗ Thanh Lam</c:v>
+                </c:pt>
+                <c:pt idx="1">
+                  <c:v>Trần Thị Bích</c:v>
+                </c:pt>
+                <c:pt idx="2">
+                  <c:v>Nguyễn Văn An</c:v>
+                </c:pt>
+                <c:pt idx="3">
+                  <c:v>Đặng Trung Kiên</c:v>
+                </c:pt>
+                <c:pt idx="4">
+                  <c:v>Phạm Quốc Dũng</c:v>
+                </c:pt>
+                <c:pt idx="5">
+                  <c:v>Lê Minh Châu</c:v>
+                </c:pt>
+                <c:pt idx="6">
+                  <c:v>Ngô Phương Oanh</c:v>
+                </c:pt>
+                <c:pt idx="7">
+                  <c:v>Vũ Đình Hùng</c:v>
+                </c:pt>
+                <c:pt idx="8">
+                  <c:v>Hoàng Thị Giang</c:v>
+                </c:pt>
+                <c:pt idx="9">
+                  <c:v>Bùi Hải Nam</c:v>
+                </c:pt>
+              </c:strCache>
+            </c:strRef>
           </c:cat>
           <c:val>
             <c:numRef>
@@ -1794,7 +1895,7 @@
                 <c:formatCode>General</c:formatCode>
                 <c:ptCount val="10"/>
                 <c:pt idx="0">
-                  <c:v>69.6</c:v>
+                  <c:v>69.599999999999994</c:v>
                 </c:pt>
                 <c:pt idx="1">
                   <c:v>32.9</c:v>
@@ -1812,7 +1913,7 @@
                   <c:v>55.7</c:v>
                 </c:pt>
                 <c:pt idx="6">
-                  <c:v>36.2</c:v>
+                  <c:v>36.200000000000003</c:v>
                 </c:pt>
                 <c:pt idx="7">
                   <c:v>51.2</c:v>
@@ -1826,6 +1927,11 @@
               </c:numCache>
             </c:numRef>
           </c:val>
+          <c:extLst>
+            <c:ext xmlns:c16="http://schemas.microsoft.com/office/drawing/2014/chart" uri="{C3380CC4-5D6E-409C-BE32-E72D297353CC}">
+              <c16:uniqueId val="{00000000-58EA-4EC3-BAA3-D42B5672CE52}"/>
+            </c:ext>
+          </c:extLst>
         </c:ser>
         <c:ser>
           <c:idx val="1"/>
@@ -1850,18 +1956,26 @@
           <c:invertIfNegative val="0"/>
           <c:dLbls>
             <c:numFmt formatCode="#,##0" sourceLinked="0"/>
+            <c:spPr>
+              <a:noFill/>
+              <a:ln>
+                <a:noFill/>
+              </a:ln>
+              <a:effectLst/>
+            </c:spPr>
             <c:txPr>
               <a:bodyPr/>
               <a:lstStyle/>
               <a:p>
                 <a:pPr>
-                  <a:defRPr b="0" i="0" strike="noStrike" sz="900" u="none">
+                  <a:defRPr sz="900" b="0" i="0" u="none" strike="noStrike">
                     <a:solidFill>
                       <a:srgbClr val="44506B"/>
                     </a:solidFill>
                     <a:latin typeface="Calibri"/>
                   </a:defRPr>
                 </a:pPr>
+                <a:endParaRPr lang="vi-VN"/>
               </a:p>
             </c:txPr>
             <c:showLegendKey val="0"/>
@@ -1871,46 +1985,49 @@
             <c:showPercent val="0"/>
             <c:showBubbleSize val="0"/>
             <c:showLeaderLines val="0"/>
+            <c:extLst>
+              <c:ext xmlns:c15="http://schemas.microsoft.com/office/drawing/2012/chart" uri="{CE6537A1-D6FC-4f65-9D91-7224C49458BB}">
+                <c15:showLeaderLines val="0"/>
+              </c:ext>
+            </c:extLst>
           </c:dLbls>
           <c:cat>
-            <c:multiLvlStrRef>
+            <c:strRef>
               <c:f>Sheet1!$A$2:$A$11</c:f>
-              <c:multiLvlStrCache>
+              <c:strCache>
                 <c:ptCount val="10"/>
-                <c:lvl>
-                  <c:pt idx="0">
-                    <c:v>Đỗ Thanh Lam</c:v>
-                  </c:pt>
-                  <c:pt idx="1">
-                    <c:v>Trần Thị Bích</c:v>
-                  </c:pt>
-                  <c:pt idx="2">
-                    <c:v>Nguyễn Văn An</c:v>
-                  </c:pt>
-                  <c:pt idx="3">
-                    <c:v>Đặng Trung Kiên</c:v>
-                  </c:pt>
-                  <c:pt idx="4">
-                    <c:v>Phạm Quốc Dũng</c:v>
-                  </c:pt>
-                  <c:pt idx="5">
-                    <c:v>Lê Minh Châu</c:v>
-                  </c:pt>
-                  <c:pt idx="6">
-                    <c:v>Ngô Phương Oanh</c:v>
-                  </c:pt>
-                  <c:pt idx="7">
-                    <c:v>Vũ Đình Hùng</c:v>
-                  </c:pt>
-                  <c:pt idx="8">
-                    <c:v>Hoàng Thị Giang</c:v>
-                  </c:pt>
-                  <c:pt idx="9">
-                    <c:v>Bùi Hải Nam</c:v>
-                  </c:pt>
-                </c:lvl>
-              </c:multiLvlStrCache>
-            </c:multiLvlStrRef>
+                <c:pt idx="0">
+                  <c:v>Đỗ Thanh Lam</c:v>
+                </c:pt>
+                <c:pt idx="1">
+                  <c:v>Trần Thị Bích</c:v>
+                </c:pt>
+                <c:pt idx="2">
+                  <c:v>Nguyễn Văn An</c:v>
+                </c:pt>
+                <c:pt idx="3">
+                  <c:v>Đặng Trung Kiên</c:v>
+                </c:pt>
+                <c:pt idx="4">
+                  <c:v>Phạm Quốc Dũng</c:v>
+                </c:pt>
+                <c:pt idx="5">
+                  <c:v>Lê Minh Châu</c:v>
+                </c:pt>
+                <c:pt idx="6">
+                  <c:v>Ngô Phương Oanh</c:v>
+                </c:pt>
+                <c:pt idx="7">
+                  <c:v>Vũ Đình Hùng</c:v>
+                </c:pt>
+                <c:pt idx="8">
+                  <c:v>Hoàng Thị Giang</c:v>
+                </c:pt>
+                <c:pt idx="9">
+                  <c:v>Bùi Hải Nam</c:v>
+                </c:pt>
+              </c:strCache>
+            </c:strRef>
           </c:cat>
           <c:val>
             <c:numRef>
@@ -1934,7 +2051,7 @@
                   <c:v>65.2</c:v>
                 </c:pt>
                 <c:pt idx="5">
-                  <c:v>71.9</c:v>
+                  <c:v>71.900000000000006</c:v>
                 </c:pt>
                 <c:pt idx="6">
                   <c:v>87.3</c:v>
@@ -1951,36 +2068,23 @@
               </c:numCache>
             </c:numRef>
           </c:val>
+          <c:extLst>
+            <c:ext xmlns:c16="http://schemas.microsoft.com/office/drawing/2014/chart" uri="{C3380CC4-5D6E-409C-BE32-E72D297353CC}">
+              <c16:uniqueId val="{00000001-58EA-4EC3-BAA3-D42B5672CE52}"/>
+            </c:ext>
+          </c:extLst>
         </c:ser>
         <c:dLbls>
-          <c:numFmt formatCode="#,##0" sourceLinked="0"/>
-          <c:txPr>
-            <a:bodyPr/>
-            <a:lstStyle/>
-            <a:p>
-              <a:pPr>
-                <a:defRPr b="0" i="0" strike="noStrike" sz="900" u="none">
-                  <a:solidFill>
-                    <a:srgbClr val="44506B"/>
-                  </a:solidFill>
-                  <a:latin typeface="Calibri"/>
-                </a:defRPr>
-              </a:pPr>
-            </a:p>
-          </c:txPr>
           <c:showLegendKey val="0"/>
           <c:showVal val="1"/>
           <c:showCatName val="0"/>
           <c:showSerName val="0"/>
           <c:showPercent val="0"/>
           <c:showBubbleSize val="0"/>
-          <c:showLeaderLines val="0"/>
         </c:dLbls>
         <c:gapWidth val="35"/>
-        <c:overlap val="0"/>
         <c:axId val="2094734554"/>
         <c:axId val="2094734552"/>
-        <c:axId val="2094734556"/>
       </c:barChart>
       <c:catAx>
         <c:axId val="2094734554"/>
@@ -2021,6 +2125,7 @@
         <c:crosses val="autoZero"/>
         <c:auto val="1"/>
         <c:lblAlgn val="ctr"/>
+        <c:lblOffset val="100"/>
         <c:noMultiLvlLbl val="1"/>
       </c:catAx>
       <c:valAx>
@@ -2105,6 +2210,7 @@
     </c:legend>
     <c:plotVisOnly val="1"/>
     <c:dispBlanksAs val="span"/>
+    <c:showDLblsOverMax val="1"/>
   </c:chart>
   <c:spPr>
     <a:noFill/>
@@ -2141,234 +2247,10 @@
           <a:chExt cx="0" cy="0"/>
         </a:xfrm>
       </p:grpSpPr>
-      <p:sp>
-        <p:nvSpPr>
-          <p:cNvPr id="2" name="Header Placeholder 1"/>
-          <p:cNvSpPr>
-            <a:spLocks noGrp="1"/>
-          </p:cNvSpPr>
-          <p:nvPr>
-            <p:ph type="hdr" sz="quarter"/>
-          </p:nvPr>
-        </p:nvSpPr>
-        <p:spPr>
-          <a:xfrm>
-            <a:off x="0" y="0"/>
-            <a:ext cx="2971800" cy="458788"/>
-          </a:xfrm>
-          <a:prstGeom prst="rect">
-            <a:avLst/>
-          </a:prstGeom>
-        </p:spPr>
-        <p:txBody>
-          <a:bodyPr vert="horz" lIns="91440" tIns="45720" rIns="91440" bIns="45720" rtlCol="0"/>
-          <a:lstStyle>
-            <a:lvl1pPr algn="l">
-              <a:defRPr sz="1200"/>
-            </a:lvl1pPr>
-          </a:lstStyle>
-          <a:p>
-            <a:endParaRPr lang="en-US"/>
-          </a:p>
-        </p:txBody>
-      </p:sp>
-      <p:sp>
-        <p:nvSpPr>
-          <p:cNvPr id="3" name="Date Placeholder 2"/>
-          <p:cNvSpPr>
-            <a:spLocks noGrp="1"/>
-          </p:cNvSpPr>
-          <p:nvPr>
-            <p:ph type="dt" idx="1"/>
-          </p:nvPr>
-        </p:nvSpPr>
-        <p:spPr>
-          <a:xfrm>
-            <a:off x="3884613" y="0"/>
-            <a:ext cx="2971800" cy="458788"/>
-          </a:xfrm>
-          <a:prstGeom prst="rect">
-            <a:avLst/>
-          </a:prstGeom>
-        </p:spPr>
-        <p:txBody>
-          <a:bodyPr vert="horz" lIns="91440" tIns="45720" rIns="91440" bIns="45720" rtlCol="0"/>
-          <a:lstStyle>
-            <a:lvl1pPr algn="r">
-              <a:defRPr sz="1200"/>
-            </a:lvl1pPr>
-          </a:lstStyle>
-          <a:p>
-            <a:fld id="{5282F153-3F37-0F45-9E97-73ACFA13230C}" type="datetimeFigureOut">
-              <a:rPr lang="en-US"/>
-              <a:t>7/23/19</a:t>
-            </a:fld>
-            <a:endParaRPr lang="en-US"/>
-          </a:p>
-        </p:txBody>
-      </p:sp>
-      <p:sp>
-        <p:nvSpPr>
-          <p:cNvPr id="4" name="Slide Image Placeholder 3"/>
-          <p:cNvSpPr>
-            <a:spLocks noGrp="1" noRot="1" noChangeAspect="1"/>
-          </p:cNvSpPr>
-          <p:nvPr>
-            <p:ph type="sldImg" idx="2"/>
-          </p:nvPr>
-        </p:nvSpPr>
-        <p:spPr>
-          <a:xfrm>
-            <a:off x="685800" y="1143000"/>
-            <a:ext cx="5486400" cy="3086100"/>
-          </a:xfrm>
-          <a:prstGeom prst="rect">
-            <a:avLst/>
-          </a:prstGeom>
-          <a:noFill/>
-          <a:ln w="12700">
-            <a:solidFill>
-              <a:prstClr val="black"/>
-            </a:solidFill>
-          </a:ln>
-        </p:spPr>
-        <p:txBody>
-          <a:bodyPr vert="horz" lIns="91440" tIns="45720" rIns="91440" bIns="45720" rtlCol="0" anchor="ctr"/>
-          <a:lstStyle/>
-          <a:p>
-            <a:endParaRPr lang="en-US"/>
-          </a:p>
-        </p:txBody>
-      </p:sp>
-      <p:sp>
-        <p:nvSpPr>
-          <p:cNvPr id="5" name="Notes Placeholder 4"/>
-          <p:cNvSpPr>
-            <a:spLocks noGrp="1"/>
-          </p:cNvSpPr>
-          <p:nvPr>
-            <p:ph type="body" sz="quarter" idx="3"/>
-          </p:nvPr>
-        </p:nvSpPr>
-        <p:spPr>
-          <a:xfrm>
-            <a:off x="685800" y="4400550"/>
-            <a:ext cx="5486400" cy="3600450"/>
-          </a:xfrm>
-          <a:prstGeom prst="rect">
-            <a:avLst/>
-          </a:prstGeom>
-        </p:spPr>
-        <p:txBody>
-          <a:bodyPr vert="horz" lIns="91440" tIns="45720" rIns="91440" bIns="45720" rtlCol="0"/>
-          <a:lstStyle/>
-          <a:p>
-            <a:pPr lvl="0"/>
-            <a:r>
-              <a:rPr lang="en-US"/>
-              <a:t>Click to edit Master text styles</a:t>
-            </a:r>
-          </a:p>
-          <a:p>
-            <a:pPr lvl="1"/>
-            <a:r>
-              <a:rPr lang="en-US"/>
-              <a:t>Second level</a:t>
-            </a:r>
-          </a:p>
-          <a:p>
-            <a:pPr lvl="2"/>
-            <a:r>
-              <a:rPr lang="en-US"/>
-              <a:t>Third level</a:t>
-            </a:r>
-          </a:p>
-          <a:p>
-            <a:pPr lvl="3"/>
-            <a:r>
-              <a:rPr lang="en-US"/>
-              <a:t>Fourth level</a:t>
-            </a:r>
-          </a:p>
-          <a:p>
-            <a:pPr lvl="4"/>
-            <a:r>
-              <a:rPr lang="en-US"/>
-              <a:t>Fifth level</a:t>
-            </a:r>
-          </a:p>
-        </p:txBody>
-      </p:sp>
-      <p:sp>
-        <p:nvSpPr>
-          <p:cNvPr id="6" name="Footer Placeholder 5"/>
-          <p:cNvSpPr>
-            <a:spLocks noGrp="1"/>
-          </p:cNvSpPr>
-          <p:nvPr>
-            <p:ph type="ftr" sz="quarter" idx="4"/>
-          </p:nvPr>
-        </p:nvSpPr>
-        <p:spPr>
-          <a:xfrm>
-            <a:off x="0" y="8685213"/>
-            <a:ext cx="2971800" cy="458787"/>
-          </a:xfrm>
-          <a:prstGeom prst="rect">
-            <a:avLst/>
-          </a:prstGeom>
-        </p:spPr>
-        <p:txBody>
-          <a:bodyPr vert="horz" lIns="91440" tIns="45720" rIns="91440" bIns="45720" rtlCol="0" anchor="b"/>
-          <a:lstStyle>
-            <a:lvl1pPr algn="l">
-              <a:defRPr sz="1200"/>
-            </a:lvl1pPr>
-          </a:lstStyle>
-          <a:p>
-            <a:endParaRPr lang="en-US"/>
-          </a:p>
-        </p:txBody>
-      </p:sp>
-      <p:sp>
-        <p:nvSpPr>
-          <p:cNvPr id="7" name="Slide Number Placeholder 6"/>
-          <p:cNvSpPr>
-            <a:spLocks noGrp="1"/>
-          </p:cNvSpPr>
-          <p:nvPr>
-            <p:ph type="sldNum" sz="quarter" idx="5"/>
-          </p:nvPr>
-        </p:nvSpPr>
-        <p:spPr>
-          <a:xfrm>
-            <a:off x="3884613" y="8685213"/>
-            <a:ext cx="2971800" cy="458787"/>
-          </a:xfrm>
-          <a:prstGeom prst="rect">
-            <a:avLst/>
-          </a:prstGeom>
-        </p:spPr>
-        <p:txBody>
-          <a:bodyPr vert="horz" lIns="91440" tIns="45720" rIns="91440" bIns="45720" rtlCol="0" anchor="b"/>
-          <a:lstStyle>
-            <a:lvl1pPr algn="r">
-              <a:defRPr sz="1200"/>
-            </a:lvl1pPr>
-          </a:lstStyle>
-          <a:p>
-            <a:fld id="{CE5E9CC1-C706-0F49-92D6-E571CC5EEA8F}" type="slidenum">
-              <a:rPr lang="en-US"/>
-              <a:t>‹#›</a:t>
-            </a:fld>
-            <a:endParaRPr lang="en-US"/>
-          </a:p>
-        </p:txBody>
-      </p:sp>
     </p:spTree>
     <p:extLst>
       <p:ext uri="{BB962C8B-B14F-4D97-AF65-F5344CB8AC3E}">
-        <p14:creationId xmlns:p14="http://schemas.microsoft.com/office/powerpoint/2010/main" val="1024086991"/>
+        <p14:creationId xmlns:p14="http://schemas.microsoft.com/office/powerpoint/2010/main" val="3865333055"/>
       </p:ext>
     </p:extLst>
   </p:cSld>
@@ -2516,7 +2398,6 @@
               <a:rPr lang="en-US" dirty="0"/>
               <a:t>Deck trình bày theo Pyramid Principle: kết luận chính ở slide 2, ba luận điểm chống đỡ ở slide 4-6.</a:t>
             </a:r>
-            <a:endParaRPr lang="en-US" dirty="0"/>
           </a:p>
         </p:txBody>
       </p:sp>
@@ -2604,7 +2485,6 @@
               <a:rPr lang="en-US" dirty="0"/>
               <a:t>Đây là đỉnh kim tự tháp. Ba thẻ bên dưới là ba luận điểm chống đỡ, mỗi luận điểm được chứng minh bằng một slide riêng.</a:t>
             </a:r>
-            <a:endParaRPr lang="en-US" dirty="0"/>
           </a:p>
         </p:txBody>
       </p:sp>
@@ -2692,7 +2572,6 @@
               <a:rPr lang="en-US" dirty="0"/>
               <a:t>Kế hoạch năm 4.350 tỷ lấy từ sheet Kế hoạch của workbook; lũy kế 6 tháng đã đạt 73,5%.</a:t>
             </a:r>
-            <a:endParaRPr lang="en-US" dirty="0"/>
           </a:p>
         </p:txBody>
       </p:sp>
@@ -2780,7 +2659,6 @@
               <a:rPr lang="en-US" dirty="0"/>
               <a:t>Bốn kênh trên năm tăng trưởng. Sự kiện mở bán tăng gấp 4,6 lần nhưng nền tháng 5 rất thấp (chỉ 2 giao dịch) — cần đọc kèm số tuyệt đối.</a:t>
             </a:r>
-            <a:endParaRPr lang="en-US" dirty="0"/>
           </a:p>
         </p:txBody>
       </p:sp>
@@ -2868,7 +2746,6 @@
               <a:rPr lang="en-US" dirty="0"/>
               <a:t>Điểm mấu chốt của toàn bộ báo cáo. Doanh thu ghi nhận trong workbook tính cả đơn đặt cọc, nên tổng số nhìn rất đẹp.</a:t>
             </a:r>
-            <a:endParaRPr lang="en-US" dirty="0"/>
           </a:p>
         </p:txBody>
       </p:sp>
@@ -2956,7 +2833,6 @@
               <a:rPr lang="en-US" dirty="0"/>
               <a:t>Mức độ tập trung là rủi ro chính: một dự án và bốn nhân viên quyết định phần lớn kết quả.</a:t>
             </a:r>
-            <a:endParaRPr lang="en-US" dirty="0"/>
           </a:p>
         </p:txBody>
       </p:sp>
@@ -3044,7 +2920,6 @@
               <a:rPr lang="en-US" dirty="0"/>
               <a:t>Bốn ô bên phải là placeholder — Colin điền nguyên nhân thực tế (chính sách bán hàng, tiến độ pháp lý dự án, biến động nhân sự...).</a:t>
             </a:r>
-            <a:endParaRPr lang="en-US" dirty="0"/>
           </a:p>
         </p:txBody>
       </p:sp>
@@ -3132,7 +3007,6 @@
               <a:rPr lang="en-US" dirty="0"/>
               <a:t>Kết thúc bằng hành động, không kết thúc bằng số liệu.</a:t>
             </a:r>
-            <a:endParaRPr lang="en-US" dirty="0"/>
           </a:p>
         </p:txBody>
       </p:sp>
@@ -3205,6 +3079,11 @@
 <file path=ppt/slideMasters/slideMaster1.xml><?xml version="1.0" encoding="utf-8"?>
 <p:sldMaster xmlns:a="http://schemas.openxmlformats.org/drawingml/2006/main" xmlns:r="http://schemas.openxmlformats.org/officeDocument/2006/relationships" xmlns:p="http://schemas.openxmlformats.org/presentationml/2006/main">
   <p:cSld>
+    <p:bg>
+      <p:bgRef idx="1001">
+        <a:schemeClr val="bg1"/>
+      </p:bgRef>
+    </p:bg>
     <p:spTree>
       <p:nvGrpSpPr>
         <p:cNvPr id="1" name=""/>
@@ -3487,6 +3366,7 @@
         <a:solidFill>
           <a:srgbClr val="1E2761"/>
         </a:solidFill>
+        <a:effectLst/>
       </p:bgPr>
     </p:bg>
     <p:spTree>
@@ -3522,6 +3402,13 @@
           </a:solidFill>
           <a:ln/>
         </p:spPr>
+        <p:txBody>
+          <a:bodyPr/>
+          <a:lstStyle/>
+          <a:p>
+            <a:endParaRPr lang="en-US"/>
+          </a:p>
+        </p:txBody>
       </p:sp>
       <p:sp>
         <p:nvSpPr>
@@ -3542,6 +3429,13 @@
           </a:solidFill>
           <a:ln/>
         </p:spPr>
+        <p:txBody>
+          <a:bodyPr/>
+          <a:lstStyle/>
+          <a:p>
+            <a:endParaRPr lang="en-US"/>
+          </a:p>
+        </p:txBody>
       </p:sp>
       <p:sp>
         <p:nvSpPr>
@@ -3564,11 +3458,11 @@
           <a:bodyPr wrap="square" lIns="0" tIns="0" rIns="0" bIns="0" rtlCol="0" anchor="ctr"/>
           <a:lstStyle/>
           <a:p>
-            <a:pPr indent="0" marL="0">
-              <a:buNone/>
-            </a:pPr>
-            <a:r>
-              <a:rPr lang="en-US" sz="1150" b="1" spc="250" kern="0" dirty="0">
+            <a:pPr marL="0" indent="0">
+              <a:buNone/>
+            </a:pPr>
+            <a:r>
+              <a:rPr lang="en-US" sz="1150" b="1" kern="0" spc="250" dirty="0">
                 <a:solidFill>
                   <a:srgbClr val="C8891F"/>
                 </a:solidFill>
@@ -3603,7 +3497,7 @@
           <a:bodyPr wrap="square" lIns="0" tIns="0" rIns="0" bIns="0" rtlCol="0" anchor="ctr"/>
           <a:lstStyle/>
           <a:p>
-            <a:pPr indent="0" marL="0">
+            <a:pPr marL="0" indent="0">
               <a:lnSpc>
                 <a:spcPts val="5000"/>
               </a:lnSpc>
@@ -3623,7 +3517,7 @@
             <a:endParaRPr lang="en-US" sz="4300" dirty="0"/>
           </a:p>
           <a:p>
-            <a:pPr indent="0" marL="0">
+            <a:pPr marL="0" indent="0">
               <a:lnSpc>
                 <a:spcPts val="5000"/>
               </a:lnSpc>
@@ -3665,7 +3559,7 @@
           <a:bodyPr wrap="square" lIns="0" tIns="0" rIns="0" bIns="0" rtlCol="0" anchor="ctr"/>
           <a:lstStyle/>
           <a:p>
-            <a:pPr indent="0" marL="0">
+            <a:pPr marL="0" indent="0">
               <a:buNone/>
             </a:pPr>
             <a:r>
@@ -3705,6 +3599,13 @@
             <a:prstDash val="solid"/>
           </a:ln>
         </p:spPr>
+        <p:txBody>
+          <a:bodyPr/>
+          <a:lstStyle/>
+          <a:p>
+            <a:endParaRPr lang="en-US"/>
+          </a:p>
+        </p:txBody>
       </p:sp>
       <p:sp>
         <p:nvSpPr>
@@ -3727,7 +3628,7 @@
           <a:bodyPr wrap="square" lIns="0" tIns="0" rIns="0" bIns="0" rtlCol="0" anchor="ctr"/>
           <a:lstStyle/>
           <a:p>
-            <a:pPr indent="0" marL="0">
+            <a:pPr marL="0" indent="0">
               <a:lnSpc>
                 <a:spcPts val="1600"/>
               </a:lnSpc>
@@ -3747,7 +3648,7 @@
             <a:endParaRPr lang="en-US" sz="1050" dirty="0"/>
           </a:p>
           <a:p>
-            <a:pPr indent="0" marL="0">
+            <a:pPr marL="0" indent="0">
               <a:lnSpc>
                 <a:spcPts val="1600"/>
               </a:lnSpc>
@@ -3784,6 +3685,7 @@
         <a:solidFill>
           <a:srgbClr val="1E2761"/>
         </a:solidFill>
+        <a:effectLst/>
       </p:bgPr>
     </p:bg>
     <p:spTree>
@@ -3821,11 +3723,11 @@
           <a:bodyPr wrap="square" lIns="0" tIns="0" rIns="0" bIns="0" rtlCol="0" anchor="ctr"/>
           <a:lstStyle/>
           <a:p>
-            <a:pPr indent="0" marL="0">
-              <a:buNone/>
-            </a:pPr>
-            <a:r>
-              <a:rPr lang="en-US" sz="1150" b="1" spc="250" kern="0" dirty="0">
+            <a:pPr marL="0" indent="0">
+              <a:buNone/>
+            </a:pPr>
+            <a:r>
+              <a:rPr lang="en-US" sz="1150" b="1" kern="0" spc="250" dirty="0">
                 <a:solidFill>
                   <a:srgbClr val="C8891F"/>
                 </a:solidFill>
@@ -3860,7 +3762,7 @@
           <a:bodyPr wrap="square" lIns="0" tIns="0" rIns="0" bIns="0" rtlCol="0" anchor="ctr"/>
           <a:lstStyle/>
           <a:p>
-            <a:pPr indent="0" marL="0">
+            <a:pPr marL="0" indent="0">
               <a:lnSpc>
                 <a:spcPts val="3600"/>
               </a:lnSpc>
@@ -3877,12 +3779,6 @@
               </a:rPr>
               <a:t>Tháng 6 tăng trưởng mạnh về quy mô (+26,6%), nhưng </a:t>
             </a:r>
-            <a:pPr indent="0" marL="0">
-              <a:lnSpc>
-                <a:spcPts val="3600"/>
-              </a:lnSpc>
-              <a:buNone/>
-            </a:pPr>
             <a:r>
               <a:rPr lang="en-US" sz="2700" b="1" dirty="0">
                 <a:solidFill>
@@ -3894,12 +3790,6 @@
               </a:rPr>
               <a:t>toàn bộ mức tăng nằm ở đơn chưa ký HĐMB</a:t>
             </a:r>
-            <a:pPr indent="0" marL="0">
-              <a:lnSpc>
-                <a:spcPts val="3600"/>
-              </a:lnSpc>
-              <a:buNone/>
-            </a:pPr>
             <a:r>
               <a:rPr lang="en-US" sz="2700" b="1" dirty="0">
                 <a:solidFill>
@@ -3941,6 +3831,13 @@
             <a:prstDash val="solid"/>
           </a:ln>
         </p:spPr>
+        <p:txBody>
+          <a:bodyPr/>
+          <a:lstStyle/>
+          <a:p>
+            <a:endParaRPr lang="en-US"/>
+          </a:p>
+        </p:txBody>
       </p:sp>
       <p:sp>
         <p:nvSpPr>
@@ -3961,6 +3858,13 @@
           </a:solidFill>
           <a:ln/>
         </p:spPr>
+        <p:txBody>
+          <a:bodyPr/>
+          <a:lstStyle/>
+          <a:p>
+            <a:endParaRPr lang="en-US"/>
+          </a:p>
+        </p:txBody>
       </p:sp>
       <p:sp>
         <p:nvSpPr>
@@ -3983,7 +3887,7 @@
           <a:bodyPr wrap="square" lIns="0" tIns="0" rIns="0" bIns="0" rtlCol="0" anchor="ctr"/>
           <a:lstStyle/>
           <a:p>
-            <a:pPr algn="ctr" indent="0" marL="0">
+            <a:pPr marL="0" indent="0" algn="ctr">
               <a:buNone/>
             </a:pPr>
             <a:r>
@@ -4022,7 +3926,7 @@
           <a:bodyPr wrap="square" lIns="0" tIns="0" rIns="0" bIns="0" rtlCol="0" anchor="ctr"/>
           <a:lstStyle/>
           <a:p>
-            <a:pPr indent="0" marL="0">
+            <a:pPr marL="0" indent="0">
               <a:lnSpc>
                 <a:spcPts val="2000"/>
               </a:lnSpc>
@@ -4064,7 +3968,7 @@
           <a:bodyPr wrap="square" lIns="0" tIns="0" rIns="0" bIns="0" rtlCol="0" anchor="ctr"/>
           <a:lstStyle/>
           <a:p>
-            <a:pPr indent="0" marL="0">
+            <a:pPr marL="0" indent="0">
               <a:lnSpc>
                 <a:spcPts val="1700"/>
               </a:lnSpc>
@@ -4106,7 +4010,7 @@
           <a:bodyPr wrap="square" lIns="0" tIns="0" rIns="0" bIns="0" rtlCol="0" anchor="ctr"/>
           <a:lstStyle/>
           <a:p>
-            <a:pPr indent="0" marL="0">
+            <a:pPr marL="0" indent="0">
               <a:buNone/>
             </a:pPr>
             <a:r>
@@ -4150,6 +4054,13 @@
             <a:prstDash val="solid"/>
           </a:ln>
         </p:spPr>
+        <p:txBody>
+          <a:bodyPr/>
+          <a:lstStyle/>
+          <a:p>
+            <a:endParaRPr lang="en-US"/>
+          </a:p>
+        </p:txBody>
       </p:sp>
       <p:sp>
         <p:nvSpPr>
@@ -4170,6 +4081,13 @@
           </a:solidFill>
           <a:ln/>
         </p:spPr>
+        <p:txBody>
+          <a:bodyPr/>
+          <a:lstStyle/>
+          <a:p>
+            <a:endParaRPr lang="en-US"/>
+          </a:p>
+        </p:txBody>
       </p:sp>
       <p:sp>
         <p:nvSpPr>
@@ -4192,7 +4110,7 @@
           <a:bodyPr wrap="square" lIns="0" tIns="0" rIns="0" bIns="0" rtlCol="0" anchor="ctr"/>
           <a:lstStyle/>
           <a:p>
-            <a:pPr algn="ctr" indent="0" marL="0">
+            <a:pPr marL="0" indent="0" algn="ctr">
               <a:buNone/>
             </a:pPr>
             <a:r>
@@ -4231,7 +4149,7 @@
           <a:bodyPr wrap="square" lIns="0" tIns="0" rIns="0" bIns="0" rtlCol="0" anchor="ctr"/>
           <a:lstStyle/>
           <a:p>
-            <a:pPr indent="0" marL="0">
+            <a:pPr marL="0" indent="0">
               <a:lnSpc>
                 <a:spcPts val="2000"/>
               </a:lnSpc>
@@ -4273,7 +4191,7 @@
           <a:bodyPr wrap="square" lIns="0" tIns="0" rIns="0" bIns="0" rtlCol="0" anchor="ctr"/>
           <a:lstStyle/>
           <a:p>
-            <a:pPr indent="0" marL="0">
+            <a:pPr marL="0" indent="0">
               <a:lnSpc>
                 <a:spcPts val="1700"/>
               </a:lnSpc>
@@ -4315,7 +4233,7 @@
           <a:bodyPr wrap="square" lIns="0" tIns="0" rIns="0" bIns="0" rtlCol="0" anchor="ctr"/>
           <a:lstStyle/>
           <a:p>
-            <a:pPr indent="0" marL="0">
+            <a:pPr marL="0" indent="0">
               <a:buNone/>
             </a:pPr>
             <a:r>
@@ -4359,6 +4277,13 @@
             <a:prstDash val="solid"/>
           </a:ln>
         </p:spPr>
+        <p:txBody>
+          <a:bodyPr/>
+          <a:lstStyle/>
+          <a:p>
+            <a:endParaRPr lang="en-US"/>
+          </a:p>
+        </p:txBody>
       </p:sp>
       <p:sp>
         <p:nvSpPr>
@@ -4379,6 +4304,13 @@
           </a:solidFill>
           <a:ln/>
         </p:spPr>
+        <p:txBody>
+          <a:bodyPr/>
+          <a:lstStyle/>
+          <a:p>
+            <a:endParaRPr lang="en-US"/>
+          </a:p>
+        </p:txBody>
       </p:sp>
       <p:sp>
         <p:nvSpPr>
@@ -4401,7 +4333,7 @@
           <a:bodyPr wrap="square" lIns="0" tIns="0" rIns="0" bIns="0" rtlCol="0" anchor="ctr"/>
           <a:lstStyle/>
           <a:p>
-            <a:pPr algn="ctr" indent="0" marL="0">
+            <a:pPr marL="0" indent="0" algn="ctr">
               <a:buNone/>
             </a:pPr>
             <a:r>
@@ -4440,7 +4372,7 @@
           <a:bodyPr wrap="square" lIns="0" tIns="0" rIns="0" bIns="0" rtlCol="0" anchor="ctr"/>
           <a:lstStyle/>
           <a:p>
-            <a:pPr indent="0" marL="0">
+            <a:pPr marL="0" indent="0">
               <a:lnSpc>
                 <a:spcPts val="2000"/>
               </a:lnSpc>
@@ -4482,7 +4414,7 @@
           <a:bodyPr wrap="square" lIns="0" tIns="0" rIns="0" bIns="0" rtlCol="0" anchor="ctr"/>
           <a:lstStyle/>
           <a:p>
-            <a:pPr indent="0" marL="0">
+            <a:pPr marL="0" indent="0">
               <a:lnSpc>
                 <a:spcPts val="1700"/>
               </a:lnSpc>
@@ -4524,7 +4456,7 @@
           <a:bodyPr wrap="square" lIns="0" tIns="0" rIns="0" bIns="0" rtlCol="0" anchor="ctr"/>
           <a:lstStyle/>
           <a:p>
-            <a:pPr indent="0" marL="0">
+            <a:pPr marL="0" indent="0">
               <a:buNone/>
             </a:pPr>
             <a:r>
@@ -4563,7 +4495,7 @@
           <a:bodyPr wrap="square" lIns="0" tIns="0" rIns="0" bIns="0" rtlCol="0" anchor="ctr"/>
           <a:lstStyle/>
           <a:p>
-            <a:pPr indent="0" marL="0">
+            <a:pPr marL="0" indent="0">
               <a:buNone/>
             </a:pPr>
             <a:r>
@@ -4597,6 +4529,7 @@
         <a:solidFill>
           <a:srgbClr val="FFFFFF"/>
         </a:solidFill>
+        <a:effectLst/>
       </p:bgPr>
     </p:bg>
     <p:spTree>
@@ -4634,11 +4567,11 @@
           <a:bodyPr wrap="square" lIns="0" tIns="0" rIns="0" bIns="0" rtlCol="0" anchor="ctr"/>
           <a:lstStyle/>
           <a:p>
-            <a:pPr indent="0" marL="0">
-              <a:buNone/>
-            </a:pPr>
-            <a:r>
-              <a:rPr lang="en-US" sz="1100" b="1" spc="200" kern="0" dirty="0">
+            <a:pPr marL="0" indent="0">
+              <a:buNone/>
+            </a:pPr>
+            <a:r>
+              <a:rPr lang="en-US" sz="1100" b="1" kern="0" spc="200" dirty="0">
                 <a:solidFill>
                   <a:srgbClr val="C8891F"/>
                 </a:solidFill>
@@ -4673,7 +4606,7 @@
           <a:bodyPr wrap="square" lIns="0" tIns="0" rIns="0" bIns="0" rtlCol="0" anchor="ctr"/>
           <a:lstStyle/>
           <a:p>
-            <a:pPr indent="0" marL="0">
+            <a:pPr marL="0" indent="0">
               <a:buNone/>
             </a:pPr>
             <a:r>
@@ -4712,7 +4645,7 @@
           <a:bodyPr wrap="square" lIns="0" tIns="0" rIns="0" bIns="0" rtlCol="0" anchor="ctr"/>
           <a:lstStyle/>
           <a:p>
-            <a:pPr indent="0" marL="0">
+            <a:pPr marL="0" indent="0">
               <a:buNone/>
             </a:pPr>
             <a:r>
@@ -4756,6 +4689,13 @@
             <a:prstDash val="solid"/>
           </a:ln>
         </p:spPr>
+        <p:txBody>
+          <a:bodyPr/>
+          <a:lstStyle/>
+          <a:p>
+            <a:endParaRPr lang="en-US"/>
+          </a:p>
+        </p:txBody>
       </p:sp>
       <p:sp>
         <p:nvSpPr>
@@ -4778,11 +4718,11 @@
           <a:bodyPr wrap="square" lIns="0" tIns="0" rIns="0" bIns="0" rtlCol="0" anchor="ctr"/>
           <a:lstStyle/>
           <a:p>
-            <a:pPr indent="0" marL="0">
-              <a:buNone/>
-            </a:pPr>
-            <a:r>
-              <a:rPr lang="en-US" sz="950" b="1" spc="100" kern="0" dirty="0">
+            <a:pPr marL="0" indent="0">
+              <a:buNone/>
+            </a:pPr>
+            <a:r>
+              <a:rPr lang="en-US" sz="950" b="1" kern="0" spc="100" dirty="0">
                 <a:solidFill>
                   <a:srgbClr val="CADCFC"/>
                 </a:solidFill>
@@ -4817,7 +4757,7 @@
           <a:bodyPr wrap="square" lIns="0" tIns="0" rIns="0" bIns="0" rtlCol="0" anchor="ctr"/>
           <a:lstStyle/>
           <a:p>
-            <a:pPr indent="0" marL="0">
+            <a:pPr marL="0" indent="0">
               <a:buNone/>
             </a:pPr>
             <a:r>
@@ -4831,9 +4771,6 @@
               </a:rPr>
               <a:t>668,7</a:t>
             </a:r>
-            <a:pPr indent="0" marL="0">
-              <a:buNone/>
-            </a:pPr>
             <a:r>
               <a:rPr lang="en-US" sz="1150" dirty="0">
                 <a:solidFill>
@@ -4870,7 +4807,7 @@
           <a:bodyPr wrap="square" lIns="0" tIns="0" rIns="0" bIns="0" rtlCol="0" anchor="ctr"/>
           <a:lstStyle/>
           <a:p>
-            <a:pPr indent="0" marL="0">
+            <a:pPr marL="0" indent="0">
               <a:buNone/>
             </a:pPr>
             <a:r>
@@ -4914,6 +4851,13 @@
             <a:prstDash val="solid"/>
           </a:ln>
         </p:spPr>
+        <p:txBody>
+          <a:bodyPr/>
+          <a:lstStyle/>
+          <a:p>
+            <a:endParaRPr lang="en-US"/>
+          </a:p>
+        </p:txBody>
       </p:sp>
       <p:sp>
         <p:nvSpPr>
@@ -4936,11 +4880,11 @@
           <a:bodyPr wrap="square" lIns="0" tIns="0" rIns="0" bIns="0" rtlCol="0" anchor="ctr"/>
           <a:lstStyle/>
           <a:p>
-            <a:pPr indent="0" marL="0">
-              <a:buNone/>
-            </a:pPr>
-            <a:r>
-              <a:rPr lang="en-US" sz="950" b="1" spc="100" kern="0" dirty="0">
+            <a:pPr marL="0" indent="0">
+              <a:buNone/>
+            </a:pPr>
+            <a:r>
+              <a:rPr lang="en-US" sz="950" b="1" kern="0" spc="100" dirty="0">
                 <a:solidFill>
                   <a:srgbClr val="6B7280"/>
                 </a:solidFill>
@@ -4975,7 +4919,7 @@
           <a:bodyPr wrap="square" lIns="0" tIns="0" rIns="0" bIns="0" rtlCol="0" anchor="ctr"/>
           <a:lstStyle/>
           <a:p>
-            <a:pPr indent="0" marL="0">
+            <a:pPr marL="0" indent="0">
               <a:buNone/>
             </a:pPr>
             <a:r>
@@ -4989,9 +4933,6 @@
               </a:rPr>
               <a:t>75</a:t>
             </a:r>
-            <a:pPr indent="0" marL="0">
-              <a:buNone/>
-            </a:pPr>
             <a:r>
               <a:rPr lang="en-US" sz="1150" dirty="0">
                 <a:solidFill>
@@ -5028,7 +4969,7 @@
           <a:bodyPr wrap="square" lIns="0" tIns="0" rIns="0" bIns="0" rtlCol="0" anchor="ctr"/>
           <a:lstStyle/>
           <a:p>
-            <a:pPr indent="0" marL="0">
+            <a:pPr marL="0" indent="0">
               <a:buNone/>
             </a:pPr>
             <a:r>
@@ -5072,6 +5013,13 @@
             <a:prstDash val="solid"/>
           </a:ln>
         </p:spPr>
+        <p:txBody>
+          <a:bodyPr/>
+          <a:lstStyle/>
+          <a:p>
+            <a:endParaRPr lang="en-US"/>
+          </a:p>
+        </p:txBody>
       </p:sp>
       <p:sp>
         <p:nvSpPr>
@@ -5094,11 +5042,11 @@
           <a:bodyPr wrap="square" lIns="0" tIns="0" rIns="0" bIns="0" rtlCol="0" anchor="ctr"/>
           <a:lstStyle/>
           <a:p>
-            <a:pPr indent="0" marL="0">
-              <a:buNone/>
-            </a:pPr>
-            <a:r>
-              <a:rPr lang="en-US" sz="950" b="1" spc="100" kern="0" dirty="0">
+            <a:pPr marL="0" indent="0">
+              <a:buNone/>
+            </a:pPr>
+            <a:r>
+              <a:rPr lang="en-US" sz="950" b="1" kern="0" spc="100" dirty="0">
                 <a:solidFill>
                   <a:srgbClr val="6B7280"/>
                 </a:solidFill>
@@ -5133,7 +5081,7 @@
           <a:bodyPr wrap="square" lIns="0" tIns="0" rIns="0" bIns="0" rtlCol="0" anchor="ctr"/>
           <a:lstStyle/>
           <a:p>
-            <a:pPr indent="0" marL="0">
+            <a:pPr marL="0" indent="0">
               <a:buNone/>
             </a:pPr>
             <a:r>
@@ -5147,9 +5095,6 @@
               </a:rPr>
               <a:t>8,92</a:t>
             </a:r>
-            <a:pPr indent="0" marL="0">
-              <a:buNone/>
-            </a:pPr>
             <a:r>
               <a:rPr lang="en-US" sz="1150" dirty="0">
                 <a:solidFill>
@@ -5186,7 +5131,7 @@
           <a:bodyPr wrap="square" lIns="0" tIns="0" rIns="0" bIns="0" rtlCol="0" anchor="ctr"/>
           <a:lstStyle/>
           <a:p>
-            <a:pPr indent="0" marL="0">
+            <a:pPr marL="0" indent="0">
               <a:buNone/>
             </a:pPr>
             <a:r>
@@ -5230,6 +5175,13 @@
             <a:prstDash val="solid"/>
           </a:ln>
         </p:spPr>
+        <p:txBody>
+          <a:bodyPr/>
+          <a:lstStyle/>
+          <a:p>
+            <a:endParaRPr lang="en-US"/>
+          </a:p>
+        </p:txBody>
       </p:sp>
       <p:sp>
         <p:nvSpPr>
@@ -5252,11 +5204,11 @@
           <a:bodyPr wrap="square" lIns="0" tIns="0" rIns="0" bIns="0" rtlCol="0" anchor="ctr"/>
           <a:lstStyle/>
           <a:p>
-            <a:pPr indent="0" marL="0">
-              <a:buNone/>
-            </a:pPr>
-            <a:r>
-              <a:rPr lang="en-US" sz="950" b="1" spc="100" kern="0" dirty="0">
+            <a:pPr marL="0" indent="0">
+              <a:buNone/>
+            </a:pPr>
+            <a:r>
+              <a:rPr lang="en-US" sz="950" b="1" kern="0" spc="100" dirty="0">
                 <a:solidFill>
                   <a:srgbClr val="6B7280"/>
                 </a:solidFill>
@@ -5291,7 +5243,7 @@
           <a:bodyPr wrap="square" lIns="0" tIns="0" rIns="0" bIns="0" rtlCol="0" anchor="ctr"/>
           <a:lstStyle/>
           <a:p>
-            <a:pPr indent="0" marL="0">
+            <a:pPr marL="0" indent="0">
               <a:buNone/>
             </a:pPr>
             <a:r>
@@ -5305,9 +5257,6 @@
               </a:rPr>
               <a:t>5,3</a:t>
             </a:r>
-            <a:pPr indent="0" marL="0">
-              <a:buNone/>
-            </a:pPr>
             <a:r>
               <a:rPr lang="en-US" sz="1150" dirty="0">
                 <a:solidFill>
@@ -5344,7 +5293,7 @@
           <a:bodyPr wrap="square" lIns="0" tIns="0" rIns="0" bIns="0" rtlCol="0" anchor="ctr"/>
           <a:lstStyle/>
           <a:p>
-            <a:pPr indent="0" marL="0">
+            <a:pPr marL="0" indent="0">
               <a:buNone/>
             </a:pPr>
             <a:r>
@@ -5388,6 +5337,13 @@
             <a:prstDash val="solid"/>
           </a:ln>
         </p:spPr>
+        <p:txBody>
+          <a:bodyPr/>
+          <a:lstStyle/>
+          <a:p>
+            <a:endParaRPr lang="en-US"/>
+          </a:p>
+        </p:txBody>
       </p:sp>
       <p:sp>
         <p:nvSpPr>
@@ -5410,11 +5366,11 @@
           <a:bodyPr wrap="square" lIns="0" tIns="0" rIns="0" bIns="0" rtlCol="0" anchor="ctr"/>
           <a:lstStyle/>
           <a:p>
-            <a:pPr indent="0" marL="0">
-              <a:buNone/>
-            </a:pPr>
-            <a:r>
-              <a:rPr lang="en-US" sz="950" b="1" spc="100" kern="0" dirty="0">
+            <a:pPr marL="0" indent="0">
+              <a:buNone/>
+            </a:pPr>
+            <a:r>
+              <a:rPr lang="en-US" sz="950" b="1" kern="0" spc="100" dirty="0">
                 <a:solidFill>
                   <a:srgbClr val="6B7280"/>
                 </a:solidFill>
@@ -5449,7 +5405,7 @@
           <a:bodyPr wrap="square" lIns="0" tIns="0" rIns="0" bIns="0" rtlCol="0" anchor="ctr"/>
           <a:lstStyle/>
           <a:p>
-            <a:pPr indent="0" marL="0">
+            <a:pPr marL="0" indent="0">
               <a:buNone/>
             </a:pPr>
             <a:r>
@@ -5463,9 +5419,6 @@
               </a:rPr>
               <a:t>78,0</a:t>
             </a:r>
-            <a:pPr indent="0" marL="0">
-              <a:buNone/>
-            </a:pPr>
             <a:r>
               <a:rPr lang="en-US" sz="1150" dirty="0">
                 <a:solidFill>
@@ -5502,7 +5455,7 @@
           <a:bodyPr wrap="square" lIns="0" tIns="0" rIns="0" bIns="0" rtlCol="0" anchor="ctr"/>
           <a:lstStyle/>
           <a:p>
-            <a:pPr indent="0" marL="0">
+            <a:pPr marL="0" indent="0">
               <a:buNone/>
             </a:pPr>
             <a:r>
@@ -5546,6 +5499,13 @@
             <a:prstDash val="solid"/>
           </a:ln>
         </p:spPr>
+        <p:txBody>
+          <a:bodyPr/>
+          <a:lstStyle/>
+          <a:p>
+            <a:endParaRPr lang="en-US"/>
+          </a:p>
+        </p:txBody>
       </p:sp>
       <p:sp>
         <p:nvSpPr>
@@ -5568,11 +5528,11 @@
           <a:bodyPr wrap="square" lIns="0" tIns="0" rIns="0" bIns="0" rtlCol="0" anchor="ctr"/>
           <a:lstStyle/>
           <a:p>
-            <a:pPr indent="0" marL="0">
-              <a:buNone/>
-            </a:pPr>
-            <a:r>
-              <a:rPr lang="en-US" sz="950" b="1" spc="100" kern="0" dirty="0">
+            <a:pPr marL="0" indent="0">
+              <a:buNone/>
+            </a:pPr>
+            <a:r>
+              <a:rPr lang="en-US" sz="950" b="1" kern="0" spc="100" dirty="0">
                 <a:solidFill>
                   <a:srgbClr val="6B7280"/>
                 </a:solidFill>
@@ -5607,7 +5567,7 @@
           <a:bodyPr wrap="square" lIns="0" tIns="0" rIns="0" bIns="0" rtlCol="0" anchor="ctr"/>
           <a:lstStyle/>
           <a:p>
-            <a:pPr indent="0" marL="0">
+            <a:pPr marL="0" indent="0">
               <a:buNone/>
             </a:pPr>
             <a:r>
@@ -5621,9 +5581,6 @@
               </a:rPr>
               <a:t>73,5</a:t>
             </a:r>
-            <a:pPr indent="0" marL="0">
-              <a:buNone/>
-            </a:pPr>
             <a:r>
               <a:rPr lang="en-US" sz="1150" dirty="0">
                 <a:solidFill>
@@ -5660,7 +5617,7 @@
           <a:bodyPr wrap="square" lIns="0" tIns="0" rIns="0" bIns="0" rtlCol="0" anchor="ctr"/>
           <a:lstStyle/>
           <a:p>
-            <a:pPr indent="0" marL="0">
+            <a:pPr marL="0" indent="0">
               <a:buNone/>
             </a:pPr>
             <a:r>
@@ -5680,17 +5637,23 @@
       </p:sp>
       <p:graphicFrame>
         <p:nvGraphicFramePr>
-          <p:cNvPr id="29" name="Chart 0" descr=""/>
+          <p:cNvPr id="29" name="Chart 0" descr="Chart"/>
           <p:cNvGraphicFramePr/>
-          <p:nvPr/>
+          <p:nvPr>
+            <p:extLst>
+              <p:ext uri="{D42A27DB-BD31-4B8C-83A1-F6EECF244321}">
+                <p14:modId xmlns:p14="http://schemas.microsoft.com/office/powerpoint/2010/main" val="2632749481"/>
+              </p:ext>
+            </p:extLst>
+          </p:nvPr>
         </p:nvGraphicFramePr>
         <p:xfrm>
           <a:off x="6720840" y="1572768"/>
           <a:ext cx="4937760" cy="3977640"/>
         </p:xfrm>
-        <a:graphic xmlns:a="http://schemas.openxmlformats.org/drawingml/2006/main">
+        <a:graphic>
           <a:graphicData uri="http://schemas.openxmlformats.org/drawingml/2006/chart">
-            <c:chart xmlns:c="http://schemas.openxmlformats.org/drawingml/2006/chart" r:id="rId1"/>
+            <c:chart xmlns:c="http://schemas.openxmlformats.org/drawingml/2006/chart" xmlns:r="http://schemas.openxmlformats.org/officeDocument/2006/relationships" r:id="rId3"/>
           </a:graphicData>
         </a:graphic>
       </p:graphicFrame>
@@ -5720,6 +5683,13 @@
             <a:prstDash val="solid"/>
           </a:ln>
         </p:spPr>
+        <p:txBody>
+          <a:bodyPr/>
+          <a:lstStyle/>
+          <a:p>
+            <a:endParaRPr lang="en-US"/>
+          </a:p>
+        </p:txBody>
       </p:sp>
       <p:sp>
         <p:nvSpPr>
@@ -5742,11 +5712,11 @@
           <a:bodyPr wrap="square" lIns="0" tIns="0" rIns="0" bIns="0" rtlCol="0" anchor="ctr"/>
           <a:lstStyle/>
           <a:p>
-            <a:pPr indent="0" marL="0">
-              <a:buNone/>
-            </a:pPr>
-            <a:r>
-              <a:rPr lang="en-US" sz="1050" b="1" spc="150" kern="0" dirty="0">
+            <a:pPr marL="0" indent="0">
+              <a:buNone/>
+            </a:pPr>
+            <a:r>
+              <a:rPr lang="en-US" sz="1050" b="1" kern="0" spc="150" dirty="0">
                 <a:solidFill>
                   <a:srgbClr val="C8891F"/>
                 </a:solidFill>
@@ -5781,7 +5751,7 @@
           <a:bodyPr wrap="square" lIns="0" tIns="0" rIns="0" bIns="0" rtlCol="0" anchor="ctr"/>
           <a:lstStyle/>
           <a:p>
-            <a:pPr indent="0" marL="0">
+            <a:pPr marL="0" indent="0">
               <a:lnSpc>
                 <a:spcPts val="1800"/>
               </a:lnSpc>
@@ -5823,7 +5793,7 @@
           <a:bodyPr wrap="square" lIns="0" tIns="0" rIns="0" bIns="0" rtlCol="0" anchor="ctr"/>
           <a:lstStyle/>
           <a:p>
-            <a:pPr indent="0" marL="0">
+            <a:pPr marL="0" indent="0">
               <a:buNone/>
             </a:pPr>
             <a:r>
@@ -5857,6 +5827,7 @@
         <a:solidFill>
           <a:srgbClr val="FFFFFF"/>
         </a:solidFill>
+        <a:effectLst/>
       </p:bgPr>
     </p:bg>
     <p:spTree>
@@ -5894,11 +5865,11 @@
           <a:bodyPr wrap="square" lIns="0" tIns="0" rIns="0" bIns="0" rtlCol="0" anchor="ctr"/>
           <a:lstStyle/>
           <a:p>
-            <a:pPr indent="0" marL="0">
-              <a:buNone/>
-            </a:pPr>
-            <a:r>
-              <a:rPr lang="en-US" sz="1100" b="1" spc="200" kern="0" dirty="0">
+            <a:pPr marL="0" indent="0">
+              <a:buNone/>
+            </a:pPr>
+            <a:r>
+              <a:rPr lang="en-US" sz="1100" b="1" kern="0" spc="200" dirty="0">
                 <a:solidFill>
                   <a:srgbClr val="C8891F"/>
                 </a:solidFill>
@@ -5933,7 +5904,7 @@
           <a:bodyPr wrap="square" lIns="0" tIns="0" rIns="0" bIns="0" rtlCol="0" anchor="ctr"/>
           <a:lstStyle/>
           <a:p>
-            <a:pPr indent="0" marL="0">
+            <a:pPr marL="0" indent="0">
               <a:buNone/>
             </a:pPr>
             <a:r>
@@ -5972,7 +5943,7 @@
           <a:bodyPr wrap="square" lIns="0" tIns="0" rIns="0" bIns="0" rtlCol="0" anchor="ctr"/>
           <a:lstStyle/>
           <a:p>
-            <a:pPr indent="0" marL="0">
+            <a:pPr marL="0" indent="0">
               <a:buNone/>
             </a:pPr>
             <a:r>
@@ -6009,6 +5980,13 @@
           </a:solidFill>
           <a:ln/>
         </p:spPr>
+        <p:txBody>
+          <a:bodyPr/>
+          <a:lstStyle/>
+          <a:p>
+            <a:endParaRPr lang="en-US"/>
+          </a:p>
+        </p:txBody>
       </p:sp>
       <p:sp>
         <p:nvSpPr>
@@ -6031,7 +6009,7 @@
           <a:bodyPr wrap="square" lIns="0" tIns="0" rIns="0" bIns="0" rtlCol="0" anchor="ctr"/>
           <a:lstStyle/>
           <a:p>
-            <a:pPr algn="ctr" indent="0" marL="0">
+            <a:pPr marL="0" indent="0" algn="ctr">
               <a:buNone/>
             </a:pPr>
             <a:r>
@@ -6051,33 +6029,45 @@
       </p:sp>
       <p:graphicFrame>
         <p:nvGraphicFramePr>
-          <p:cNvPr id="7" name="Chart 0" descr=""/>
+          <p:cNvPr id="7" name="Chart 0" descr="Chart"/>
           <p:cNvGraphicFramePr/>
-          <p:nvPr/>
+          <p:nvPr>
+            <p:extLst>
+              <p:ext uri="{D42A27DB-BD31-4B8C-83A1-F6EECF244321}">
+                <p14:modId xmlns:p14="http://schemas.microsoft.com/office/powerpoint/2010/main" val="2010752443"/>
+              </p:ext>
+            </p:extLst>
+          </p:nvPr>
         </p:nvGraphicFramePr>
         <p:xfrm>
           <a:off x="502920" y="1627632"/>
           <a:ext cx="5623560" cy="3246120"/>
         </p:xfrm>
-        <a:graphic xmlns:a="http://schemas.openxmlformats.org/drawingml/2006/main">
+        <a:graphic>
           <a:graphicData uri="http://schemas.openxmlformats.org/drawingml/2006/chart">
-            <c:chart xmlns:c="http://schemas.openxmlformats.org/drawingml/2006/chart" r:id="rId1"/>
+            <c:chart xmlns:c="http://schemas.openxmlformats.org/drawingml/2006/chart" xmlns:r="http://schemas.openxmlformats.org/officeDocument/2006/relationships" r:id="rId3"/>
           </a:graphicData>
         </a:graphic>
       </p:graphicFrame>
       <p:graphicFrame>
         <p:nvGraphicFramePr>
-          <p:cNvPr id="8" name="Chart 1" descr=""/>
+          <p:cNvPr id="8" name="Chart 1" descr="Chart"/>
           <p:cNvGraphicFramePr/>
-          <p:nvPr/>
+          <p:nvPr>
+            <p:extLst>
+              <p:ext uri="{D42A27DB-BD31-4B8C-83A1-F6EECF244321}">
+                <p14:modId xmlns:p14="http://schemas.microsoft.com/office/powerpoint/2010/main" val="2977833529"/>
+              </p:ext>
+            </p:extLst>
+          </p:nvPr>
         </p:nvGraphicFramePr>
         <p:xfrm>
           <a:off x="6263640" y="1627632"/>
           <a:ext cx="5440680" cy="3246120"/>
         </p:xfrm>
-        <a:graphic xmlns:a="http://schemas.openxmlformats.org/drawingml/2006/main">
+        <a:graphic>
           <a:graphicData uri="http://schemas.openxmlformats.org/drawingml/2006/chart">
-            <c:chart xmlns:c="http://schemas.openxmlformats.org/drawingml/2006/chart" r:id="rId2"/>
+            <c:chart xmlns:c="http://schemas.openxmlformats.org/drawingml/2006/chart" xmlns:r="http://schemas.openxmlformats.org/officeDocument/2006/relationships" r:id="rId4"/>
           </a:graphicData>
         </a:graphic>
       </p:graphicFrame>
@@ -6107,6 +6097,13 @@
             <a:prstDash val="solid"/>
           </a:ln>
         </p:spPr>
+        <p:txBody>
+          <a:bodyPr/>
+          <a:lstStyle/>
+          <a:p>
+            <a:endParaRPr lang="en-US"/>
+          </a:p>
+        </p:txBody>
       </p:sp>
       <p:sp>
         <p:nvSpPr>
@@ -6129,7 +6126,7 @@
           <a:bodyPr wrap="square" lIns="0" tIns="0" rIns="0" bIns="0" rtlCol="0" anchor="ctr"/>
           <a:lstStyle/>
           <a:p>
-            <a:pPr indent="0" marL="0">
+            <a:pPr marL="0" indent="0">
               <a:buNone/>
             </a:pPr>
             <a:r>
@@ -6143,9 +6140,6 @@
               </a:rPr>
               <a:t>Sự kiện mở bán  </a:t>
             </a:r>
-            <a:pPr indent="0" marL="0">
-              <a:buNone/>
-            </a:pPr>
             <a:r>
               <a:rPr lang="en-US" sz="1400" b="1" dirty="0">
                 <a:solidFill>
@@ -6182,7 +6176,7 @@
           <a:bodyPr wrap="square" lIns="0" tIns="0" rIns="0" bIns="0" rtlCol="0" anchor="ctr"/>
           <a:lstStyle/>
           <a:p>
-            <a:pPr indent="0" marL="0">
+            <a:pPr marL="0" indent="0">
               <a:lnSpc>
                 <a:spcPts val="1400"/>
               </a:lnSpc>
@@ -6229,6 +6223,13 @@
             <a:prstDash val="solid"/>
           </a:ln>
         </p:spPr>
+        <p:txBody>
+          <a:bodyPr/>
+          <a:lstStyle/>
+          <a:p>
+            <a:endParaRPr lang="en-US"/>
+          </a:p>
+        </p:txBody>
       </p:sp>
       <p:sp>
         <p:nvSpPr>
@@ -6251,7 +6252,7 @@
           <a:bodyPr wrap="square" lIns="0" tIns="0" rIns="0" bIns="0" rtlCol="0" anchor="ctr"/>
           <a:lstStyle/>
           <a:p>
-            <a:pPr indent="0" marL="0">
+            <a:pPr marL="0" indent="0">
               <a:buNone/>
             </a:pPr>
             <a:r>
@@ -6265,9 +6266,6 @@
               </a:rPr>
               <a:t>Online / Digital  </a:t>
             </a:r>
-            <a:pPr indent="0" marL="0">
-              <a:buNone/>
-            </a:pPr>
             <a:r>
               <a:rPr lang="en-US" sz="1400" b="1" dirty="0">
                 <a:solidFill>
@@ -6304,7 +6302,7 @@
           <a:bodyPr wrap="square" lIns="0" tIns="0" rIns="0" bIns="0" rtlCol="0" anchor="ctr"/>
           <a:lstStyle/>
           <a:p>
-            <a:pPr indent="0" marL="0">
+            <a:pPr marL="0" indent="0">
               <a:lnSpc>
                 <a:spcPts val="1400"/>
               </a:lnSpc>
@@ -6351,6 +6349,13 @@
             <a:prstDash val="solid"/>
           </a:ln>
         </p:spPr>
+        <p:txBody>
+          <a:bodyPr/>
+          <a:lstStyle/>
+          <a:p>
+            <a:endParaRPr lang="en-US"/>
+          </a:p>
+        </p:txBody>
       </p:sp>
       <p:sp>
         <p:nvSpPr>
@@ -6373,7 +6378,7 @@
           <a:bodyPr wrap="square" lIns="0" tIns="0" rIns="0" bIns="0" rtlCol="0" anchor="ctr"/>
           <a:lstStyle/>
           <a:p>
-            <a:pPr indent="0" marL="0">
+            <a:pPr marL="0" indent="0">
               <a:buNone/>
             </a:pPr>
             <a:r>
@@ -6387,9 +6392,6 @@
               </a:rPr>
               <a:t>Biệt thự  </a:t>
             </a:r>
-            <a:pPr indent="0" marL="0">
-              <a:buNone/>
-            </a:pPr>
             <a:r>
               <a:rPr lang="en-US" sz="1400" b="1" dirty="0">
                 <a:solidFill>
@@ -6426,7 +6428,7 @@
           <a:bodyPr wrap="square" lIns="0" tIns="0" rIns="0" bIns="0" rtlCol="0" anchor="ctr"/>
           <a:lstStyle/>
           <a:p>
-            <a:pPr indent="0" marL="0">
+            <a:pPr marL="0" indent="0">
               <a:lnSpc>
                 <a:spcPts val="1400"/>
               </a:lnSpc>
@@ -6473,6 +6475,13 @@
             <a:prstDash val="solid"/>
           </a:ln>
         </p:spPr>
+        <p:txBody>
+          <a:bodyPr/>
+          <a:lstStyle/>
+          <a:p>
+            <a:endParaRPr lang="en-US"/>
+          </a:p>
+        </p:txBody>
       </p:sp>
       <p:sp>
         <p:nvSpPr>
@@ -6495,7 +6504,7 @@
           <a:bodyPr wrap="square" lIns="0" tIns="0" rIns="0" bIns="0" rtlCol="0" anchor="ctr"/>
           <a:lstStyle/>
           <a:p>
-            <a:pPr indent="0" marL="0">
+            <a:pPr marL="0" indent="0">
               <a:buNone/>
             </a:pPr>
             <a:r>
@@ -6509,9 +6518,6 @@
               </a:rPr>
               <a:t>Khách giới thiệu  </a:t>
             </a:r>
-            <a:pPr indent="0" marL="0">
-              <a:buNone/>
-            </a:pPr>
             <a:r>
               <a:rPr lang="en-US" sz="1400" b="1" dirty="0">
                 <a:solidFill>
@@ -6548,7 +6554,7 @@
           <a:bodyPr wrap="square" lIns="0" tIns="0" rIns="0" bIns="0" rtlCol="0" anchor="ctr"/>
           <a:lstStyle/>
           <a:p>
-            <a:pPr indent="0" marL="0">
+            <a:pPr marL="0" indent="0">
               <a:lnSpc>
                 <a:spcPts val="1400"/>
               </a:lnSpc>
@@ -6585,6 +6591,7 @@
         <a:solidFill>
           <a:srgbClr val="FFFFFF"/>
         </a:solidFill>
+        <a:effectLst/>
       </p:bgPr>
     </p:bg>
     <p:spTree>
@@ -6622,11 +6629,11 @@
           <a:bodyPr wrap="square" lIns="0" tIns="0" rIns="0" bIns="0" rtlCol="0" anchor="ctr"/>
           <a:lstStyle/>
           <a:p>
-            <a:pPr indent="0" marL="0">
-              <a:buNone/>
-            </a:pPr>
-            <a:r>
-              <a:rPr lang="en-US" sz="1100" b="1" spc="200" kern="0" dirty="0">
+            <a:pPr marL="0" indent="0">
+              <a:buNone/>
+            </a:pPr>
+            <a:r>
+              <a:rPr lang="en-US" sz="1100" b="1" kern="0" spc="200" dirty="0">
                 <a:solidFill>
                   <a:srgbClr val="C8891F"/>
                 </a:solidFill>
@@ -6661,7 +6668,7 @@
           <a:bodyPr wrap="square" lIns="0" tIns="0" rIns="0" bIns="0" rtlCol="0" anchor="ctr"/>
           <a:lstStyle/>
           <a:p>
-            <a:pPr indent="0" marL="0">
+            <a:pPr marL="0" indent="0">
               <a:buNone/>
             </a:pPr>
             <a:r>
@@ -6700,7 +6707,7 @@
           <a:bodyPr wrap="square" lIns="0" tIns="0" rIns="0" bIns="0" rtlCol="0" anchor="ctr"/>
           <a:lstStyle/>
           <a:p>
-            <a:pPr indent="0" marL="0">
+            <a:pPr marL="0" indent="0">
               <a:buNone/>
             </a:pPr>
             <a:r>
@@ -6737,6 +6744,13 @@
           </a:solidFill>
           <a:ln/>
         </p:spPr>
+        <p:txBody>
+          <a:bodyPr/>
+          <a:lstStyle/>
+          <a:p>
+            <a:endParaRPr lang="en-US"/>
+          </a:p>
+        </p:txBody>
       </p:sp>
       <p:sp>
         <p:nvSpPr>
@@ -6759,7 +6773,7 @@
           <a:bodyPr wrap="square" lIns="0" tIns="0" rIns="0" bIns="0" rtlCol="0" anchor="ctr"/>
           <a:lstStyle/>
           <a:p>
-            <a:pPr algn="ctr" indent="0" marL="0">
+            <a:pPr marL="0" indent="0" algn="ctr">
               <a:buNone/>
             </a:pPr>
             <a:r>
@@ -6779,17 +6793,23 @@
       </p:sp>
       <p:graphicFrame>
         <p:nvGraphicFramePr>
-          <p:cNvPr id="7" name="Chart 0" descr=""/>
+          <p:cNvPr id="7" name="Chart 0" descr="Chart"/>
           <p:cNvGraphicFramePr/>
-          <p:nvPr/>
+          <p:nvPr>
+            <p:extLst>
+              <p:ext uri="{D42A27DB-BD31-4B8C-83A1-F6EECF244321}">
+                <p14:modId xmlns:p14="http://schemas.microsoft.com/office/powerpoint/2010/main" val="267348746"/>
+              </p:ext>
+            </p:extLst>
+          </p:nvPr>
         </p:nvGraphicFramePr>
         <p:xfrm>
           <a:off x="502920" y="1691640"/>
           <a:ext cx="6537960" cy="3566160"/>
         </p:xfrm>
-        <a:graphic xmlns:a="http://schemas.openxmlformats.org/drawingml/2006/main">
+        <a:graphic>
           <a:graphicData uri="http://schemas.openxmlformats.org/drawingml/2006/chart">
-            <c:chart xmlns:c="http://schemas.openxmlformats.org/drawingml/2006/chart" r:id="rId1"/>
+            <c:chart xmlns:c="http://schemas.openxmlformats.org/drawingml/2006/chart" xmlns:r="http://schemas.openxmlformats.org/officeDocument/2006/relationships" r:id="rId3"/>
           </a:graphicData>
         </a:graphic>
       </p:graphicFrame>
@@ -6819,6 +6839,13 @@
             <a:prstDash val="solid"/>
           </a:ln>
         </p:spPr>
+        <p:txBody>
+          <a:bodyPr/>
+          <a:lstStyle/>
+          <a:p>
+            <a:endParaRPr lang="en-US"/>
+          </a:p>
+        </p:txBody>
       </p:sp>
       <p:sp>
         <p:nvSpPr>
@@ -6841,7 +6868,7 @@
           <a:bodyPr wrap="square" lIns="0" tIns="0" rIns="0" bIns="0" rtlCol="0" anchor="ctr"/>
           <a:lstStyle/>
           <a:p>
-            <a:pPr indent="0" marL="0">
+            <a:pPr marL="0" indent="0">
               <a:buNone/>
             </a:pPr>
             <a:r>
@@ -6880,7 +6907,7 @@
           <a:bodyPr wrap="square" lIns="0" tIns="0" rIns="0" bIns="0" rtlCol="0" anchor="ctr"/>
           <a:lstStyle/>
           <a:p>
-            <a:pPr indent="0" marL="0">
+            <a:pPr marL="0" indent="0">
               <a:buNone/>
             </a:pPr>
             <a:r>
@@ -6919,7 +6946,7 @@
           <a:bodyPr wrap="square" lIns="0" tIns="0" rIns="0" bIns="0" rtlCol="0" anchor="ctr"/>
           <a:lstStyle/>
           <a:p>
-            <a:pPr indent="0" marL="0">
+            <a:pPr marL="0" indent="0">
               <a:lnSpc>
                 <a:spcPts val="1400"/>
               </a:lnSpc>
@@ -6966,6 +6993,13 @@
             <a:prstDash val="solid"/>
           </a:ln>
         </p:spPr>
+        <p:txBody>
+          <a:bodyPr/>
+          <a:lstStyle/>
+          <a:p>
+            <a:endParaRPr lang="en-US"/>
+          </a:p>
+        </p:txBody>
       </p:sp>
       <p:sp>
         <p:nvSpPr>
@@ -6988,7 +7022,7 @@
           <a:bodyPr wrap="square" lIns="0" tIns="0" rIns="0" bIns="0" rtlCol="0" anchor="ctr"/>
           <a:lstStyle/>
           <a:p>
-            <a:pPr indent="0" marL="0">
+            <a:pPr marL="0" indent="0">
               <a:buNone/>
             </a:pPr>
             <a:r>
@@ -7027,7 +7061,7 @@
           <a:bodyPr wrap="square" lIns="0" tIns="0" rIns="0" bIns="0" rtlCol="0" anchor="ctr"/>
           <a:lstStyle/>
           <a:p>
-            <a:pPr indent="0" marL="0">
+            <a:pPr marL="0" indent="0">
               <a:buNone/>
             </a:pPr>
             <a:r>
@@ -7066,7 +7100,7 @@
           <a:bodyPr wrap="square" lIns="0" tIns="0" rIns="0" bIns="0" rtlCol="0" anchor="ctr"/>
           <a:lstStyle/>
           <a:p>
-            <a:pPr indent="0" marL="0">
+            <a:pPr marL="0" indent="0">
               <a:lnSpc>
                 <a:spcPts val="1400"/>
               </a:lnSpc>
@@ -7113,6 +7147,13 @@
             <a:prstDash val="solid"/>
           </a:ln>
         </p:spPr>
+        <p:txBody>
+          <a:bodyPr/>
+          <a:lstStyle/>
+          <a:p>
+            <a:endParaRPr lang="en-US"/>
+          </a:p>
+        </p:txBody>
       </p:sp>
       <p:sp>
         <p:nvSpPr>
@@ -7135,7 +7176,7 @@
           <a:bodyPr wrap="square" lIns="0" tIns="0" rIns="0" bIns="0" rtlCol="0" anchor="ctr"/>
           <a:lstStyle/>
           <a:p>
-            <a:pPr indent="0" marL="0">
+            <a:pPr marL="0" indent="0">
               <a:buNone/>
             </a:pPr>
             <a:r>
@@ -7174,7 +7215,7 @@
           <a:bodyPr wrap="square" lIns="0" tIns="0" rIns="0" bIns="0" rtlCol="0" anchor="ctr"/>
           <a:lstStyle/>
           <a:p>
-            <a:pPr indent="0" marL="0">
+            <a:pPr marL="0" indent="0">
               <a:buNone/>
             </a:pPr>
             <a:r>
@@ -7213,7 +7254,7 @@
           <a:bodyPr wrap="square" lIns="0" tIns="0" rIns="0" bIns="0" rtlCol="0" anchor="ctr"/>
           <a:lstStyle/>
           <a:p>
-            <a:pPr indent="0" marL="0">
+            <a:pPr marL="0" indent="0">
               <a:lnSpc>
                 <a:spcPts val="1400"/>
               </a:lnSpc>
@@ -7260,6 +7301,13 @@
             <a:prstDash val="solid"/>
           </a:ln>
         </p:spPr>
+        <p:txBody>
+          <a:bodyPr/>
+          <a:lstStyle/>
+          <a:p>
+            <a:endParaRPr lang="en-US"/>
+          </a:p>
+        </p:txBody>
       </p:sp>
       <p:sp>
         <p:nvSpPr>
@@ -7282,7 +7330,7 @@
           <a:bodyPr wrap="square" lIns="0" tIns="0" rIns="0" bIns="0" rtlCol="0" anchor="ctr"/>
           <a:lstStyle/>
           <a:p>
-            <a:pPr indent="0" marL="0">
+            <a:pPr marL="0" indent="0">
               <a:buNone/>
             </a:pPr>
             <a:r>
@@ -7321,7 +7369,7 @@
           <a:bodyPr wrap="square" lIns="0" tIns="0" rIns="0" bIns="0" rtlCol="0" anchor="ctr"/>
           <a:lstStyle/>
           <a:p>
-            <a:pPr indent="0" marL="0">
+            <a:pPr marL="0" indent="0">
               <a:buNone/>
             </a:pPr>
             <a:r>
@@ -7360,7 +7408,7 @@
           <a:bodyPr wrap="square" lIns="0" tIns="0" rIns="0" bIns="0" rtlCol="0" anchor="ctr"/>
           <a:lstStyle/>
           <a:p>
-            <a:pPr indent="0" marL="0">
+            <a:pPr marL="0" indent="0">
               <a:lnSpc>
                 <a:spcPts val="1400"/>
               </a:lnSpc>
@@ -7407,6 +7455,13 @@
             <a:prstDash val="solid"/>
           </a:ln>
         </p:spPr>
+        <p:txBody>
+          <a:bodyPr/>
+          <a:lstStyle/>
+          <a:p>
+            <a:endParaRPr lang="en-US"/>
+          </a:p>
+        </p:txBody>
       </p:sp>
       <p:sp>
         <p:nvSpPr>
@@ -7429,7 +7484,7 @@
           <a:bodyPr wrap="square" lIns="0" tIns="0" rIns="0" bIns="0" rtlCol="0" anchor="ctr"/>
           <a:lstStyle/>
           <a:p>
-            <a:pPr indent="0" marL="0">
+            <a:pPr marL="0" indent="0">
               <a:lnSpc>
                 <a:spcPts val="1700"/>
               </a:lnSpc>
@@ -7446,12 +7501,6 @@
               </a:rPr>
               <a:t>Ý nghĩa:  </a:t>
             </a:r>
-            <a:pPr indent="0" marL="0">
-              <a:lnSpc>
-                <a:spcPts val="1700"/>
-              </a:lnSpc>
-              <a:buNone/>
-            </a:pPr>
             <a:r>
               <a:rPr lang="en-US" sz="1250" dirty="0">
                 <a:solidFill>
@@ -7483,6 +7532,7 @@
         <a:solidFill>
           <a:srgbClr val="FFFFFF"/>
         </a:solidFill>
+        <a:effectLst/>
       </p:bgPr>
     </p:bg>
     <p:spTree>
@@ -7520,11 +7570,11 @@
           <a:bodyPr wrap="square" lIns="0" tIns="0" rIns="0" bIns="0" rtlCol="0" anchor="ctr"/>
           <a:lstStyle/>
           <a:p>
-            <a:pPr indent="0" marL="0">
-              <a:buNone/>
-            </a:pPr>
-            <a:r>
-              <a:rPr lang="en-US" sz="1100" b="1" spc="200" kern="0" dirty="0">
+            <a:pPr marL="0" indent="0">
+              <a:buNone/>
+            </a:pPr>
+            <a:r>
+              <a:rPr lang="en-US" sz="1100" b="1" kern="0" spc="200" dirty="0">
                 <a:solidFill>
                   <a:srgbClr val="C8891F"/>
                 </a:solidFill>
@@ -7559,7 +7609,7 @@
           <a:bodyPr wrap="square" lIns="0" tIns="0" rIns="0" bIns="0" rtlCol="0" anchor="ctr"/>
           <a:lstStyle/>
           <a:p>
-            <a:pPr indent="0" marL="0">
+            <a:pPr marL="0" indent="0">
               <a:buNone/>
             </a:pPr>
             <a:r>
@@ -7598,7 +7648,7 @@
           <a:bodyPr wrap="square" lIns="0" tIns="0" rIns="0" bIns="0" rtlCol="0" anchor="ctr"/>
           <a:lstStyle/>
           <a:p>
-            <a:pPr indent="0" marL="0">
+            <a:pPr marL="0" indent="0">
               <a:buNone/>
             </a:pPr>
             <a:r>
@@ -7635,6 +7685,13 @@
           </a:solidFill>
           <a:ln/>
         </p:spPr>
+        <p:txBody>
+          <a:bodyPr/>
+          <a:lstStyle/>
+          <a:p>
+            <a:endParaRPr lang="en-US"/>
+          </a:p>
+        </p:txBody>
       </p:sp>
       <p:sp>
         <p:nvSpPr>
@@ -7657,7 +7714,7 @@
           <a:bodyPr wrap="square" lIns="0" tIns="0" rIns="0" bIns="0" rtlCol="0" anchor="ctr"/>
           <a:lstStyle/>
           <a:p>
-            <a:pPr algn="ctr" indent="0" marL="0">
+            <a:pPr marL="0" indent="0" algn="ctr">
               <a:buNone/>
             </a:pPr>
             <a:r>
@@ -7677,17 +7734,23 @@
       </p:sp>
       <p:graphicFrame>
         <p:nvGraphicFramePr>
-          <p:cNvPr id="7" name="Chart 0" descr=""/>
+          <p:cNvPr id="7" name="Chart 0" descr="Chart"/>
           <p:cNvGraphicFramePr/>
-          <p:nvPr/>
+          <p:nvPr>
+            <p:extLst>
+              <p:ext uri="{D42A27DB-BD31-4B8C-83A1-F6EECF244321}">
+                <p14:modId xmlns:p14="http://schemas.microsoft.com/office/powerpoint/2010/main" val="1617321313"/>
+              </p:ext>
+            </p:extLst>
+          </p:nvPr>
         </p:nvGraphicFramePr>
         <p:xfrm>
           <a:off x="502920" y="1664208"/>
           <a:ext cx="6675120" cy="4069080"/>
         </p:xfrm>
-        <a:graphic xmlns:a="http://schemas.openxmlformats.org/drawingml/2006/main">
+        <a:graphic>
           <a:graphicData uri="http://schemas.openxmlformats.org/drawingml/2006/chart">
-            <c:chart xmlns:c="http://schemas.openxmlformats.org/drawingml/2006/chart" r:id="rId1"/>
+            <c:chart xmlns:c="http://schemas.openxmlformats.org/drawingml/2006/chart" xmlns:r="http://schemas.openxmlformats.org/officeDocument/2006/relationships" r:id="rId3"/>
           </a:graphicData>
         </a:graphic>
       </p:graphicFrame>
@@ -7717,6 +7780,13 @@
             <a:prstDash val="solid"/>
           </a:ln>
         </p:spPr>
+        <p:txBody>
+          <a:bodyPr/>
+          <a:lstStyle/>
+          <a:p>
+            <a:endParaRPr lang="en-US"/>
+          </a:p>
+        </p:txBody>
       </p:sp>
       <p:sp>
         <p:nvSpPr>
@@ -7739,11 +7809,11 @@
           <a:bodyPr wrap="square" lIns="0" tIns="0" rIns="0" bIns="0" rtlCol="0" anchor="ctr"/>
           <a:lstStyle/>
           <a:p>
-            <a:pPr indent="0" marL="0">
-              <a:buNone/>
-            </a:pPr>
-            <a:r>
-              <a:rPr lang="en-US" sz="950" b="1" spc="100" kern="0" dirty="0">
+            <a:pPr marL="0" indent="0">
+              <a:buNone/>
+            </a:pPr>
+            <a:r>
+              <a:rPr lang="en-US" sz="950" b="1" kern="0" spc="100" dirty="0">
                 <a:solidFill>
                   <a:srgbClr val="6B7280"/>
                 </a:solidFill>
@@ -7778,7 +7848,7 @@
           <a:bodyPr wrap="square" lIns="0" tIns="0" rIns="0" bIns="0" rtlCol="0" anchor="ctr"/>
           <a:lstStyle/>
           <a:p>
-            <a:pPr indent="0" marL="0">
+            <a:pPr marL="0" indent="0">
               <a:buNone/>
             </a:pPr>
             <a:r>
@@ -7792,9 +7862,6 @@
               </a:rPr>
               <a:t>63</a:t>
             </a:r>
-            <a:pPr indent="0" marL="0">
-              <a:buNone/>
-            </a:pPr>
             <a:r>
               <a:rPr lang="en-US" sz="1150" dirty="0">
                 <a:solidFill>
@@ -7831,7 +7898,7 @@
           <a:bodyPr wrap="square" lIns="0" tIns="0" rIns="0" bIns="0" rtlCol="0" anchor="ctr"/>
           <a:lstStyle/>
           <a:p>
-            <a:pPr indent="0" marL="0">
+            <a:pPr marL="0" indent="0">
               <a:buNone/>
             </a:pPr>
             <a:r>
@@ -7875,6 +7942,13 @@
             <a:prstDash val="solid"/>
           </a:ln>
         </p:spPr>
+        <p:txBody>
+          <a:bodyPr/>
+          <a:lstStyle/>
+          <a:p>
+            <a:endParaRPr lang="en-US"/>
+          </a:p>
+        </p:txBody>
       </p:sp>
       <p:sp>
         <p:nvSpPr>
@@ -7897,11 +7971,11 @@
           <a:bodyPr wrap="square" lIns="0" tIns="0" rIns="0" bIns="0" rtlCol="0" anchor="ctr"/>
           <a:lstStyle/>
           <a:p>
-            <a:pPr indent="0" marL="0">
-              <a:buNone/>
-            </a:pPr>
-            <a:r>
-              <a:rPr lang="en-US" sz="950" b="1" spc="100" kern="0" dirty="0">
+            <a:pPr marL="0" indent="0">
+              <a:buNone/>
+            </a:pPr>
+            <a:r>
+              <a:rPr lang="en-US" sz="950" b="1" kern="0" spc="100" dirty="0">
                 <a:solidFill>
                   <a:srgbClr val="6B7280"/>
                 </a:solidFill>
@@ -7936,7 +8010,7 @@
           <a:bodyPr wrap="square" lIns="0" tIns="0" rIns="0" bIns="0" rtlCol="0" anchor="ctr"/>
           <a:lstStyle/>
           <a:p>
-            <a:pPr indent="0" marL="0">
+            <a:pPr marL="0" indent="0">
               <a:buNone/>
             </a:pPr>
             <a:r>
@@ -7950,9 +8024,6 @@
               </a:rPr>
               <a:t>22</a:t>
             </a:r>
-            <a:pPr indent="0" marL="0">
-              <a:buNone/>
-            </a:pPr>
             <a:r>
               <a:rPr lang="en-US" sz="1150" dirty="0">
                 <a:solidFill>
@@ -7989,7 +8060,7 @@
           <a:bodyPr wrap="square" lIns="0" tIns="0" rIns="0" bIns="0" rtlCol="0" anchor="ctr"/>
           <a:lstStyle/>
           <a:p>
-            <a:pPr indent="0" marL="0">
+            <a:pPr marL="0" indent="0">
               <a:buNone/>
             </a:pPr>
             <a:r>
@@ -8028,7 +8099,7 @@
           <a:bodyPr wrap="square" lIns="0" tIns="0" rIns="0" bIns="0" rtlCol="0" anchor="ctr"/>
           <a:lstStyle/>
           <a:p>
-            <a:pPr indent="0" marL="0">
+            <a:pPr marL="0" indent="0">
               <a:buNone/>
             </a:pPr>
             <a:r>
@@ -8070,6 +8141,13 @@
             <a:prstDash val="solid"/>
           </a:ln>
         </p:spPr>
+        <p:txBody>
+          <a:bodyPr/>
+          <a:lstStyle/>
+          <a:p>
+            <a:endParaRPr lang="en-US"/>
+          </a:p>
+        </p:txBody>
       </p:sp>
       <p:sp>
         <p:nvSpPr>
@@ -8092,7 +8170,7 @@
           <a:bodyPr wrap="square" lIns="0" tIns="0" rIns="0" bIns="0" rtlCol="0" anchor="ctr"/>
           <a:lstStyle/>
           <a:p>
-            <a:pPr indent="0" marL="0">
+            <a:pPr marL="0" indent="0">
               <a:buNone/>
             </a:pPr>
             <a:r>
@@ -8131,7 +8209,7 @@
           <a:bodyPr wrap="square" lIns="0" tIns="0" rIns="0" bIns="0" rtlCol="0" anchor="ctr"/>
           <a:lstStyle/>
           <a:p>
-            <a:pPr algn="r" indent="0" marL="0">
+            <a:pPr marL="0" indent="0" algn="r">
               <a:buNone/>
             </a:pPr>
             <a:r>
@@ -8170,7 +8248,7 @@
           <a:bodyPr wrap="square" lIns="0" tIns="0" rIns="0" bIns="0" rtlCol="0" anchor="ctr"/>
           <a:lstStyle/>
           <a:p>
-            <a:pPr algn="r" indent="0" marL="0">
+            <a:pPr marL="0" indent="0" algn="r">
               <a:buNone/>
             </a:pPr>
             <a:r>
@@ -8209,7 +8287,7 @@
           <a:bodyPr wrap="square" lIns="0" tIns="0" rIns="0" bIns="0" rtlCol="0" anchor="ctr"/>
           <a:lstStyle/>
           <a:p>
-            <a:pPr indent="0" marL="0">
+            <a:pPr marL="0" indent="0">
               <a:buNone/>
             </a:pPr>
             <a:r>
@@ -8248,7 +8326,7 @@
           <a:bodyPr wrap="square" lIns="0" tIns="0" rIns="0" bIns="0" rtlCol="0" anchor="ctr"/>
           <a:lstStyle/>
           <a:p>
-            <a:pPr algn="r" indent="0" marL="0">
+            <a:pPr marL="0" indent="0" algn="r">
               <a:buNone/>
             </a:pPr>
             <a:r>
@@ -8287,7 +8365,7 @@
           <a:bodyPr wrap="square" lIns="0" tIns="0" rIns="0" bIns="0" rtlCol="0" anchor="ctr"/>
           <a:lstStyle/>
           <a:p>
-            <a:pPr algn="r" indent="0" marL="0">
+            <a:pPr marL="0" indent="0" algn="r">
               <a:buNone/>
             </a:pPr>
             <a:r>
@@ -8329,6 +8407,13 @@
             <a:prstDash val="solid"/>
           </a:ln>
         </p:spPr>
+        <p:txBody>
+          <a:bodyPr/>
+          <a:lstStyle/>
+          <a:p>
+            <a:endParaRPr lang="en-US"/>
+          </a:p>
+        </p:txBody>
       </p:sp>
       <p:sp>
         <p:nvSpPr>
@@ -8351,7 +8436,7 @@
           <a:bodyPr wrap="square" lIns="0" tIns="0" rIns="0" bIns="0" rtlCol="0" anchor="ctr"/>
           <a:lstStyle/>
           <a:p>
-            <a:pPr indent="0" marL="0">
+            <a:pPr marL="0" indent="0">
               <a:buNone/>
             </a:pPr>
             <a:r>
@@ -8390,7 +8475,7 @@
           <a:bodyPr wrap="square" lIns="0" tIns="0" rIns="0" bIns="0" rtlCol="0" anchor="ctr"/>
           <a:lstStyle/>
           <a:p>
-            <a:pPr algn="r" indent="0" marL="0">
+            <a:pPr marL="0" indent="0" algn="r">
               <a:buNone/>
             </a:pPr>
             <a:r>
@@ -8429,7 +8514,7 @@
           <a:bodyPr wrap="square" lIns="0" tIns="0" rIns="0" bIns="0" rtlCol="0" anchor="ctr"/>
           <a:lstStyle/>
           <a:p>
-            <a:pPr algn="r" indent="0" marL="0">
+            <a:pPr marL="0" indent="0" algn="r">
               <a:buNone/>
             </a:pPr>
             <a:r>
@@ -8468,7 +8553,7 @@
           <a:bodyPr wrap="square" lIns="0" tIns="0" rIns="0" bIns="0" rtlCol="0" anchor="ctr"/>
           <a:lstStyle/>
           <a:p>
-            <a:pPr indent="0" marL="0">
+            <a:pPr marL="0" indent="0">
               <a:buNone/>
             </a:pPr>
             <a:r>
@@ -8507,7 +8592,7 @@
           <a:bodyPr wrap="square" lIns="0" tIns="0" rIns="0" bIns="0" rtlCol="0" anchor="ctr"/>
           <a:lstStyle/>
           <a:p>
-            <a:pPr algn="r" indent="0" marL="0">
+            <a:pPr marL="0" indent="0" algn="r">
               <a:buNone/>
             </a:pPr>
             <a:r>
@@ -8546,7 +8631,7 @@
           <a:bodyPr wrap="square" lIns="0" tIns="0" rIns="0" bIns="0" rtlCol="0" anchor="ctr"/>
           <a:lstStyle/>
           <a:p>
-            <a:pPr algn="r" indent="0" marL="0">
+            <a:pPr marL="0" indent="0" algn="r">
               <a:buNone/>
             </a:pPr>
             <a:r>
@@ -8588,6 +8673,13 @@
             <a:prstDash val="solid"/>
           </a:ln>
         </p:spPr>
+        <p:txBody>
+          <a:bodyPr/>
+          <a:lstStyle/>
+          <a:p>
+            <a:endParaRPr lang="en-US"/>
+          </a:p>
+        </p:txBody>
       </p:sp>
       <p:sp>
         <p:nvSpPr>
@@ -8610,7 +8702,7 @@
           <a:bodyPr wrap="square" lIns="0" tIns="0" rIns="0" bIns="0" rtlCol="0" anchor="ctr"/>
           <a:lstStyle/>
           <a:p>
-            <a:pPr indent="0" marL="0">
+            <a:pPr marL="0" indent="0">
               <a:buNone/>
             </a:pPr>
             <a:r>
@@ -8649,7 +8741,7 @@
           <a:bodyPr wrap="square" lIns="0" tIns="0" rIns="0" bIns="0" rtlCol="0" anchor="ctr"/>
           <a:lstStyle/>
           <a:p>
-            <a:pPr algn="r" indent="0" marL="0">
+            <a:pPr marL="0" indent="0" algn="r">
               <a:buNone/>
             </a:pPr>
             <a:r>
@@ -8688,7 +8780,7 @@
           <a:bodyPr wrap="square" lIns="0" tIns="0" rIns="0" bIns="0" rtlCol="0" anchor="ctr"/>
           <a:lstStyle/>
           <a:p>
-            <a:pPr algn="r" indent="0" marL="0">
+            <a:pPr marL="0" indent="0" algn="r">
               <a:buNone/>
             </a:pPr>
             <a:r>
@@ -8727,7 +8819,7 @@
           <a:bodyPr wrap="square" lIns="0" tIns="0" rIns="0" bIns="0" rtlCol="0" anchor="ctr"/>
           <a:lstStyle/>
           <a:p>
-            <a:pPr indent="0" marL="0">
+            <a:pPr marL="0" indent="0">
               <a:buNone/>
             </a:pPr>
             <a:r>
@@ -8766,7 +8858,7 @@
           <a:bodyPr wrap="square" lIns="0" tIns="0" rIns="0" bIns="0" rtlCol="0" anchor="ctr"/>
           <a:lstStyle/>
           <a:p>
-            <a:pPr algn="r" indent="0" marL="0">
+            <a:pPr marL="0" indent="0" algn="r">
               <a:buNone/>
             </a:pPr>
             <a:r>
@@ -8805,7 +8897,7 @@
           <a:bodyPr wrap="square" lIns="0" tIns="0" rIns="0" bIns="0" rtlCol="0" anchor="ctr"/>
           <a:lstStyle/>
           <a:p>
-            <a:pPr algn="r" indent="0" marL="0">
+            <a:pPr marL="0" indent="0" algn="r">
               <a:buNone/>
             </a:pPr>
             <a:r>
@@ -8844,7 +8936,7 @@
           <a:bodyPr wrap="square" lIns="0" tIns="0" rIns="0" bIns="0" rtlCol="0" anchor="ctr"/>
           <a:lstStyle/>
           <a:p>
-            <a:pPr indent="0" marL="0">
+            <a:pPr marL="0" indent="0">
               <a:lnSpc>
                 <a:spcPts val="1400"/>
               </a:lnSpc>
@@ -8881,6 +8973,7 @@
         <a:solidFill>
           <a:srgbClr val="FFFFFF"/>
         </a:solidFill>
+        <a:effectLst/>
       </p:bgPr>
     </p:bg>
     <p:spTree>
@@ -8918,11 +9011,11 @@
           <a:bodyPr wrap="square" lIns="0" tIns="0" rIns="0" bIns="0" rtlCol="0" anchor="ctr"/>
           <a:lstStyle/>
           <a:p>
-            <a:pPr indent="0" marL="0">
-              <a:buNone/>
-            </a:pPr>
-            <a:r>
-              <a:rPr lang="en-US" sz="1100" b="1" spc="200" kern="0" dirty="0">
+            <a:pPr marL="0" indent="0">
+              <a:buNone/>
+            </a:pPr>
+            <a:r>
+              <a:rPr lang="en-US" sz="1100" b="1" kern="0" spc="200" dirty="0">
                 <a:solidFill>
                   <a:srgbClr val="C8891F"/>
                 </a:solidFill>
@@ -8957,7 +9050,7 @@
           <a:bodyPr wrap="square" lIns="0" tIns="0" rIns="0" bIns="0" rtlCol="0" anchor="ctr"/>
           <a:lstStyle/>
           <a:p>
-            <a:pPr indent="0" marL="0">
+            <a:pPr marL="0" indent="0">
               <a:buNone/>
             </a:pPr>
             <a:r>
@@ -8996,11 +9089,11 @@
           <a:bodyPr wrap="square" lIns="0" tIns="0" rIns="0" bIns="0" rtlCol="0" anchor="ctr"/>
           <a:lstStyle/>
           <a:p>
-            <a:pPr indent="0" marL="0">
-              <a:buNone/>
-            </a:pPr>
-            <a:r>
-              <a:rPr lang="en-US" sz="1300" dirty="0">
+            <a:pPr marL="0" indent="0">
+              <a:buNone/>
+            </a:pPr>
+            <a:r>
+              <a:rPr lang="vi-VN" sz="1300">
                 <a:solidFill>
                   <a:srgbClr val="6B7280"/>
                 </a:solidFill>
@@ -9008,7 +9101,7 @@
                 <a:ea typeface="Calibri" pitchFamily="34" charset="-122"/>
                 <a:cs typeface="Calibri" pitchFamily="34" charset="-120"/>
               </a:rPr>
-              <a:t>Phần “Nguyên nhân” để trống — anh/chị điền bối cảnh thực tế trước khi trình bày</a:t>
+              <a:t>Nguyên nhân đề xuất dựa trên dữ liệu tháng 6 — anh/chị rà soát, bổ sung bối cảnh thực tế trước khi trình bày</a:t>
             </a:r>
             <a:endParaRPr lang="en-US" sz="1300" dirty="0"/>
           </a:p>
@@ -9040,6 +9133,13 @@
             <a:prstDash val="solid"/>
           </a:ln>
         </p:spPr>
+        <p:txBody>
+          <a:bodyPr/>
+          <a:lstStyle/>
+          <a:p>
+            <a:endParaRPr lang="en-US"/>
+          </a:p>
+        </p:txBody>
       </p:sp>
       <p:sp>
         <p:nvSpPr>
@@ -9060,6 +9160,13 @@
           </a:solidFill>
           <a:ln/>
         </p:spPr>
+        <p:txBody>
+          <a:bodyPr/>
+          <a:lstStyle/>
+          <a:p>
+            <a:endParaRPr lang="en-US"/>
+          </a:p>
+        </p:txBody>
       </p:sp>
       <p:sp>
         <p:nvSpPr>
@@ -9082,7 +9189,7 @@
           <a:bodyPr wrap="square" lIns="0" tIns="0" rIns="0" bIns="0" rtlCol="0" anchor="ctr"/>
           <a:lstStyle/>
           <a:p>
-            <a:pPr algn="ctr" indent="0" marL="0">
+            <a:pPr marL="0" indent="0" algn="ctr">
               <a:buNone/>
             </a:pPr>
             <a:r>
@@ -9121,7 +9228,7 @@
           <a:bodyPr wrap="square" lIns="0" tIns="0" rIns="0" bIns="0" rtlCol="0" anchor="ctr"/>
           <a:lstStyle/>
           <a:p>
-            <a:pPr indent="0" marL="0">
+            <a:pPr marL="0" indent="0">
               <a:buNone/>
             </a:pPr>
             <a:r>
@@ -9160,7 +9267,7 @@
           <a:bodyPr wrap="square" lIns="0" tIns="0" rIns="0" bIns="0" rtlCol="0" anchor="ctr"/>
           <a:lstStyle/>
           <a:p>
-            <a:pPr indent="0" marL="0">
+            <a:pPr marL="0" indent="0">
               <a:lnSpc>
                 <a:spcPts val="1400"/>
               </a:lnSpc>
@@ -9207,6 +9314,13 @@
             <a:prstDash val="dash"/>
           </a:ln>
         </p:spPr>
+        <p:txBody>
+          <a:bodyPr/>
+          <a:lstStyle/>
+          <a:p>
+            <a:endParaRPr lang="en-US"/>
+          </a:p>
+        </p:txBody>
       </p:sp>
       <p:sp>
         <p:nvSpPr>
@@ -9229,11 +9343,11 @@
           <a:bodyPr wrap="square" lIns="0" tIns="0" rIns="0" bIns="0" rtlCol="0" anchor="ctr"/>
           <a:lstStyle/>
           <a:p>
-            <a:pPr indent="0" marL="0">
-              <a:buNone/>
-            </a:pPr>
-            <a:r>
-              <a:rPr lang="en-US" sz="900" b="1" spc="150" kern="0" dirty="0">
+            <a:pPr marL="0" indent="0">
+              <a:buNone/>
+            </a:pPr>
+            <a:r>
+              <a:rPr lang="en-US" sz="900" b="1" kern="0" spc="150" dirty="0">
                 <a:solidFill>
                   <a:srgbClr val="9AA3B5"/>
                 </a:solidFill>
@@ -9268,19 +9382,19 @@
           <a:bodyPr wrap="square" lIns="0" tIns="0" rIns="0" bIns="0" rtlCol="0" anchor="ctr"/>
           <a:lstStyle/>
           <a:p>
-            <a:pPr indent="0" marL="0">
-              <a:buNone/>
-            </a:pPr>
-            <a:r>
-              <a:rPr lang="en-US" sz="1200" i="1" dirty="0">
-                <a:solidFill>
-                  <a:srgbClr val="B9C2D6"/>
+            <a:pPr marL="0" indent="0">
+              <a:buNone/>
+            </a:pPr>
+            <a:r>
+              <a:rPr lang="vi-VN" sz="1200">
+                <a:solidFill>
+                  <a:srgbClr val="3C4A63"/>
                 </a:solidFill>
                 <a:latin typeface="Calibri" pitchFamily="34" charset="0"/>
                 <a:ea typeface="Calibri" pitchFamily="34" charset="-122"/>
                 <a:cs typeface="Calibri" pitchFamily="34" charset="-120"/>
               </a:rPr>
-              <a:t>[ Điền tại đây ]</a:t>
+              <a:t>Swan Bay Villas mở bán mới trong tháng 6, các đơn còn ở giai đoạn đặt cọc và chưa đến kỳ ký HĐMB; đồng thời chính sách đẩy mạnh giữ chỗ tại sự kiện mở bán khiến lượng cọc tăng nhanh hơn tốc độ ký hợp đồng.</a:t>
             </a:r>
             <a:endParaRPr lang="en-US" sz="1200" dirty="0"/>
           </a:p>
@@ -9312,6 +9426,13 @@
             <a:prstDash val="solid"/>
           </a:ln>
         </p:spPr>
+        <p:txBody>
+          <a:bodyPr/>
+          <a:lstStyle/>
+          <a:p>
+            <a:endParaRPr lang="en-US"/>
+          </a:p>
+        </p:txBody>
       </p:sp>
       <p:sp>
         <p:nvSpPr>
@@ -9332,6 +9453,13 @@
           </a:solidFill>
           <a:ln/>
         </p:spPr>
+        <p:txBody>
+          <a:bodyPr/>
+          <a:lstStyle/>
+          <a:p>
+            <a:endParaRPr lang="en-US"/>
+          </a:p>
+        </p:txBody>
       </p:sp>
       <p:sp>
         <p:nvSpPr>
@@ -9354,7 +9482,7 @@
           <a:bodyPr wrap="square" lIns="0" tIns="0" rIns="0" bIns="0" rtlCol="0" anchor="ctr"/>
           <a:lstStyle/>
           <a:p>
-            <a:pPr algn="ctr" indent="0" marL="0">
+            <a:pPr marL="0" indent="0" algn="ctr">
               <a:buNone/>
             </a:pPr>
             <a:r>
@@ -9393,7 +9521,7 @@
           <a:bodyPr wrap="square" lIns="0" tIns="0" rIns="0" bIns="0" rtlCol="0" anchor="ctr"/>
           <a:lstStyle/>
           <a:p>
-            <a:pPr indent="0" marL="0">
+            <a:pPr marL="0" indent="0">
               <a:buNone/>
             </a:pPr>
             <a:r>
@@ -9432,7 +9560,7 @@
           <a:bodyPr wrap="square" lIns="0" tIns="0" rIns="0" bIns="0" rtlCol="0" anchor="ctr"/>
           <a:lstStyle/>
           <a:p>
-            <a:pPr indent="0" marL="0">
+            <a:pPr marL="0" indent="0">
               <a:lnSpc>
                 <a:spcPts val="1400"/>
               </a:lnSpc>
@@ -9479,6 +9607,13 @@
             <a:prstDash val="dash"/>
           </a:ln>
         </p:spPr>
+        <p:txBody>
+          <a:bodyPr/>
+          <a:lstStyle/>
+          <a:p>
+            <a:endParaRPr lang="en-US"/>
+          </a:p>
+        </p:txBody>
       </p:sp>
       <p:sp>
         <p:nvSpPr>
@@ -9501,11 +9636,11 @@
           <a:bodyPr wrap="square" lIns="0" tIns="0" rIns="0" bIns="0" rtlCol="0" anchor="ctr"/>
           <a:lstStyle/>
           <a:p>
-            <a:pPr indent="0" marL="0">
-              <a:buNone/>
-            </a:pPr>
-            <a:r>
-              <a:rPr lang="en-US" sz="900" b="1" spc="150" kern="0" dirty="0">
+            <a:pPr marL="0" indent="0">
+              <a:buNone/>
+            </a:pPr>
+            <a:r>
+              <a:rPr lang="en-US" sz="900" b="1" kern="0" spc="150" dirty="0">
                 <a:solidFill>
                   <a:srgbClr val="9AA3B5"/>
                 </a:solidFill>
@@ -9540,19 +9675,19 @@
           <a:bodyPr wrap="square" lIns="0" tIns="0" rIns="0" bIns="0" rtlCol="0" anchor="ctr"/>
           <a:lstStyle/>
           <a:p>
-            <a:pPr indent="0" marL="0">
-              <a:buNone/>
-            </a:pPr>
-            <a:r>
-              <a:rPr lang="en-US" sz="1200" i="1" dirty="0">
-                <a:solidFill>
-                  <a:srgbClr val="B9C2D6"/>
+            <a:pPr marL="0" indent="0">
+              <a:buNone/>
+            </a:pPr>
+            <a:r>
+              <a:rPr lang="en-US" sz="1200">
+                <a:solidFill>
+                  <a:srgbClr val="3C4A63"/>
                 </a:solidFill>
                 <a:latin typeface="Calibri" pitchFamily="34" charset="0"/>
                 <a:ea typeface="Calibri" pitchFamily="34" charset="-122"/>
                 <a:cs typeface="Calibri" pitchFamily="34" charset="-120"/>
               </a:rPr>
-              <a:t>[ Điền tại đây ]</a:t>
+              <a:t>Tháng 6 tập trung ngân sách cho sự kiện mở bán dự án mới và mở rộng quảng cáo số, trong khi sàn nội bộ F1 dồn nguồn lực phục vụ sự kiện nên tỷ trọng khai thác khách tự có giảm.</a:t>
             </a:r>
             <a:endParaRPr lang="en-US" sz="1200" dirty="0"/>
           </a:p>
@@ -9584,6 +9719,13 @@
             <a:prstDash val="solid"/>
           </a:ln>
         </p:spPr>
+        <p:txBody>
+          <a:bodyPr/>
+          <a:lstStyle/>
+          <a:p>
+            <a:endParaRPr lang="en-US"/>
+          </a:p>
+        </p:txBody>
       </p:sp>
       <p:sp>
         <p:nvSpPr>
@@ -9604,6 +9746,13 @@
           </a:solidFill>
           <a:ln/>
         </p:spPr>
+        <p:txBody>
+          <a:bodyPr/>
+          <a:lstStyle/>
+          <a:p>
+            <a:endParaRPr lang="en-US"/>
+          </a:p>
+        </p:txBody>
       </p:sp>
       <p:sp>
         <p:nvSpPr>
@@ -9626,7 +9775,7 @@
           <a:bodyPr wrap="square" lIns="0" tIns="0" rIns="0" bIns="0" rtlCol="0" anchor="ctr"/>
           <a:lstStyle/>
           <a:p>
-            <a:pPr algn="ctr" indent="0" marL="0">
+            <a:pPr marL="0" indent="0" algn="ctr">
               <a:buNone/>
             </a:pPr>
             <a:r>
@@ -9665,7 +9814,7 @@
           <a:bodyPr wrap="square" lIns="0" tIns="0" rIns="0" bIns="0" rtlCol="0" anchor="ctr"/>
           <a:lstStyle/>
           <a:p>
-            <a:pPr indent="0" marL="0">
+            <a:pPr marL="0" indent="0">
               <a:buNone/>
             </a:pPr>
             <a:r>
@@ -9704,7 +9853,7 @@
           <a:bodyPr wrap="square" lIns="0" tIns="0" rIns="0" bIns="0" rtlCol="0" anchor="ctr"/>
           <a:lstStyle/>
           <a:p>
-            <a:pPr indent="0" marL="0">
+            <a:pPr marL="0" indent="0">
               <a:lnSpc>
                 <a:spcPts val="1400"/>
               </a:lnSpc>
@@ -9751,6 +9900,13 @@
             <a:prstDash val="dash"/>
           </a:ln>
         </p:spPr>
+        <p:txBody>
+          <a:bodyPr/>
+          <a:lstStyle/>
+          <a:p>
+            <a:endParaRPr lang="en-US"/>
+          </a:p>
+        </p:txBody>
       </p:sp>
       <p:sp>
         <p:nvSpPr>
@@ -9773,11 +9929,11 @@
           <a:bodyPr wrap="square" lIns="0" tIns="0" rIns="0" bIns="0" rtlCol="0" anchor="ctr"/>
           <a:lstStyle/>
           <a:p>
-            <a:pPr indent="0" marL="0">
-              <a:buNone/>
-            </a:pPr>
-            <a:r>
-              <a:rPr lang="en-US" sz="900" b="1" spc="150" kern="0" dirty="0">
+            <a:pPr marL="0" indent="0">
+              <a:buNone/>
+            </a:pPr>
+            <a:r>
+              <a:rPr lang="en-US" sz="900" b="1" kern="0" spc="150" dirty="0">
                 <a:solidFill>
                   <a:srgbClr val="9AA3B5"/>
                 </a:solidFill>
@@ -9812,19 +9968,19 @@
           <a:bodyPr wrap="square" lIns="0" tIns="0" rIns="0" bIns="0" rtlCol="0" anchor="ctr"/>
           <a:lstStyle/>
           <a:p>
-            <a:pPr indent="0" marL="0">
-              <a:buNone/>
-            </a:pPr>
-            <a:r>
-              <a:rPr lang="en-US" sz="1200" i="1" dirty="0">
-                <a:solidFill>
-                  <a:srgbClr val="B9C2D6"/>
+            <a:pPr marL="0" indent="0">
+              <a:buNone/>
+            </a:pPr>
+            <a:r>
+              <a:rPr lang="vi-VN" sz="1200">
+                <a:solidFill>
+                  <a:srgbClr val="3C4A63"/>
                 </a:solidFill>
                 <a:latin typeface="Calibri" pitchFamily="34" charset="0"/>
                 <a:ea typeface="Calibri" pitchFamily="34" charset="-122"/>
                 <a:cs typeface="Calibri" pitchFamily="34" charset="-120"/>
               </a:rPr>
-              <a:t>[ Điền tại đây ]</a:t>
+              <a:t>Cơ cấu sản phẩm dịch sang đất nền có đơn giá trên m² thấp hơn, kèm chính sách chiết khấu ưu đãi áp dụng cho giỏ hàng đất nền và khách đặt cọc sớm tại sự kiện mở bán.</a:t>
             </a:r>
             <a:endParaRPr lang="en-US" sz="1200" dirty="0"/>
           </a:p>
@@ -9856,6 +10012,13 @@
             <a:prstDash val="solid"/>
           </a:ln>
         </p:spPr>
+        <p:txBody>
+          <a:bodyPr/>
+          <a:lstStyle/>
+          <a:p>
+            <a:endParaRPr lang="en-US"/>
+          </a:p>
+        </p:txBody>
       </p:sp>
       <p:sp>
         <p:nvSpPr>
@@ -9876,6 +10039,13 @@
           </a:solidFill>
           <a:ln/>
         </p:spPr>
+        <p:txBody>
+          <a:bodyPr/>
+          <a:lstStyle/>
+          <a:p>
+            <a:endParaRPr lang="en-US"/>
+          </a:p>
+        </p:txBody>
       </p:sp>
       <p:sp>
         <p:nvSpPr>
@@ -9898,7 +10068,7 @@
           <a:bodyPr wrap="square" lIns="0" tIns="0" rIns="0" bIns="0" rtlCol="0" anchor="ctr"/>
           <a:lstStyle/>
           <a:p>
-            <a:pPr algn="ctr" indent="0" marL="0">
+            <a:pPr marL="0" indent="0" algn="ctr">
               <a:buNone/>
             </a:pPr>
             <a:r>
@@ -9937,7 +10107,7 @@
           <a:bodyPr wrap="square" lIns="0" tIns="0" rIns="0" bIns="0" rtlCol="0" anchor="ctr"/>
           <a:lstStyle/>
           <a:p>
-            <a:pPr indent="0" marL="0">
+            <a:pPr marL="0" indent="0">
               <a:buNone/>
             </a:pPr>
             <a:r>
@@ -9976,7 +10146,7 @@
           <a:bodyPr wrap="square" lIns="0" tIns="0" rIns="0" bIns="0" rtlCol="0" anchor="ctr"/>
           <a:lstStyle/>
           <a:p>
-            <a:pPr indent="0" marL="0">
+            <a:pPr marL="0" indent="0">
               <a:lnSpc>
                 <a:spcPts val="1400"/>
               </a:lnSpc>
@@ -10023,6 +10193,13 @@
             <a:prstDash val="dash"/>
           </a:ln>
         </p:spPr>
+        <p:txBody>
+          <a:bodyPr/>
+          <a:lstStyle/>
+          <a:p>
+            <a:endParaRPr lang="en-US"/>
+          </a:p>
+        </p:txBody>
       </p:sp>
       <p:sp>
         <p:nvSpPr>
@@ -10045,11 +10222,11 @@
           <a:bodyPr wrap="square" lIns="0" tIns="0" rIns="0" bIns="0" rtlCol="0" anchor="ctr"/>
           <a:lstStyle/>
           <a:p>
-            <a:pPr indent="0" marL="0">
-              <a:buNone/>
-            </a:pPr>
-            <a:r>
-              <a:rPr lang="en-US" sz="900" b="1" spc="150" kern="0" dirty="0">
+            <a:pPr marL="0" indent="0">
+              <a:buNone/>
+            </a:pPr>
+            <a:r>
+              <a:rPr lang="en-US" sz="900" b="1" kern="0" spc="150" dirty="0">
                 <a:solidFill>
                   <a:srgbClr val="9AA3B5"/>
                 </a:solidFill>
@@ -10072,31 +10249,53 @@
         <p:spPr>
           <a:xfrm>
             <a:off x="7360920" y="5458968"/>
-            <a:ext cx="4023360" cy="457200"/>
-          </a:xfrm>
-          <a:prstGeom prst="rect">
-            <a:avLst/>
-          </a:prstGeom>
-          <a:noFill/>
-          <a:ln/>
-        </p:spPr>
-        <p:txBody>
-          <a:bodyPr wrap="square" lIns="0" tIns="0" rIns="0" bIns="0" rtlCol="0" anchor="ctr"/>
-          <a:lstStyle/>
-          <a:p>
-            <a:pPr indent="0" marL="0">
-              <a:buNone/>
-            </a:pPr>
-            <a:r>
-              <a:rPr lang="en-US" sz="1200" i="1" dirty="0">
-                <a:solidFill>
-                  <a:srgbClr val="B9C2D6"/>
+            <a:ext cx="4023360" cy="576072"/>
+          </a:xfrm>
+          <a:prstGeom prst="rect">
+            <a:avLst/>
+          </a:prstGeom>
+          <a:noFill/>
+          <a:ln/>
+        </p:spPr>
+        <p:txBody>
+          <a:bodyPr wrap="square" lIns="0" tIns="0" rIns="0" bIns="0" rtlCol="0" anchor="ctr"/>
+          <a:lstStyle/>
+          <a:p>
+            <a:pPr marL="0" indent="0">
+              <a:buNone/>
+            </a:pPr>
+            <a:r>
+              <a:rPr lang="vi-VN" sz="1200" dirty="0">
+                <a:solidFill>
+                  <a:srgbClr val="3C4A63"/>
                 </a:solidFill>
                 <a:latin typeface="Calibri" pitchFamily="34" charset="0"/>
                 <a:ea typeface="Calibri" pitchFamily="34" charset="-122"/>
                 <a:cs typeface="Calibri" pitchFamily="34" charset="-120"/>
               </a:rPr>
-              <a:t>[ Điền tại đây ]</a:t>
+              <a:t>Kết quả dồn vào nhóm </a:t>
+            </a:r>
+            <a:r>
+              <a:rPr lang="vi-VN" sz="1200" dirty="0" err="1">
+                <a:solidFill>
+                  <a:srgbClr val="3C4A63"/>
+                </a:solidFill>
+                <a:latin typeface="Calibri" pitchFamily="34" charset="0"/>
+                <a:ea typeface="Calibri" pitchFamily="34" charset="-122"/>
+                <a:cs typeface="Calibri" pitchFamily="34" charset="-120"/>
+              </a:rPr>
+              <a:t>sales</a:t>
+            </a:r>
+            <a:r>
+              <a:rPr lang="vi-VN" sz="1200" dirty="0">
+                <a:solidFill>
+                  <a:srgbClr val="3C4A63"/>
+                </a:solidFill>
+                <a:latin typeface="Calibri" pitchFamily="34" charset="0"/>
+                <a:ea typeface="Calibri" pitchFamily="34" charset="-122"/>
+                <a:cs typeface="Calibri" pitchFamily="34" charset="-120"/>
+              </a:rPr>
+              <a:t> được phân giỏ hàng dự án mới mở bán, trong khi bốn nhân viên còn lại phụ trách các dự án đã qua cao điểm bán hàng hoặc đang vướng tiến độ pháp lý, nguồn hàng hạn chế.</a:t>
             </a:r>
             <a:endParaRPr lang="en-US" sz="1200" dirty="0"/>
           </a:p>
@@ -10118,6 +10317,7 @@
         <a:solidFill>
           <a:srgbClr val="1E2761"/>
         </a:solidFill>
+        <a:effectLst/>
       </p:bgPr>
     </p:bg>
     <p:spTree>
@@ -10155,11 +10355,11 @@
           <a:bodyPr wrap="square" lIns="0" tIns="0" rIns="0" bIns="0" rtlCol="0" anchor="ctr"/>
           <a:lstStyle/>
           <a:p>
-            <a:pPr indent="0" marL="0">
-              <a:buNone/>
-            </a:pPr>
-            <a:r>
-              <a:rPr lang="en-US" sz="1150" b="1" spc="250" kern="0" dirty="0">
+            <a:pPr marL="0" indent="0">
+              <a:buNone/>
+            </a:pPr>
+            <a:r>
+              <a:rPr lang="en-US" sz="1150" b="1" kern="0" spc="250" dirty="0">
                 <a:solidFill>
                   <a:srgbClr val="C8891F"/>
                 </a:solidFill>
@@ -10194,7 +10394,7 @@
           <a:bodyPr wrap="square" lIns="0" tIns="0" rIns="0" bIns="0" rtlCol="0" anchor="ctr"/>
           <a:lstStyle/>
           <a:p>
-            <a:pPr indent="0" marL="0">
+            <a:pPr marL="0" indent="0">
               <a:buNone/>
             </a:pPr>
             <a:r>
@@ -10233,7 +10433,7 @@
           <a:bodyPr wrap="square" lIns="0" tIns="0" rIns="0" bIns="0" rtlCol="0" anchor="ctr"/>
           <a:lstStyle/>
           <a:p>
-            <a:pPr indent="0" marL="0">
+            <a:pPr marL="0" indent="0">
               <a:buNone/>
             </a:pPr>
             <a:r>
@@ -10277,6 +10477,13 @@
             <a:prstDash val="solid"/>
           </a:ln>
         </p:spPr>
+        <p:txBody>
+          <a:bodyPr/>
+          <a:lstStyle/>
+          <a:p>
+            <a:endParaRPr lang="en-US"/>
+          </a:p>
+        </p:txBody>
       </p:sp>
       <p:sp>
         <p:nvSpPr>
@@ -10297,6 +10504,13 @@
           </a:solidFill>
           <a:ln/>
         </p:spPr>
+        <p:txBody>
+          <a:bodyPr/>
+          <a:lstStyle/>
+          <a:p>
+            <a:endParaRPr lang="en-US"/>
+          </a:p>
+        </p:txBody>
       </p:sp>
       <p:sp>
         <p:nvSpPr>
@@ -10319,7 +10533,7 @@
           <a:bodyPr wrap="square" lIns="0" tIns="0" rIns="0" bIns="0" rtlCol="0" anchor="ctr"/>
           <a:lstStyle/>
           <a:p>
-            <a:pPr algn="ctr" indent="0" marL="0">
+            <a:pPr marL="0" indent="0" algn="ctr">
               <a:buNone/>
             </a:pPr>
             <a:r>
@@ -10358,7 +10572,7 @@
           <a:bodyPr wrap="square" lIns="0" tIns="0" rIns="0" bIns="0" rtlCol="0" anchor="ctr"/>
           <a:lstStyle/>
           <a:p>
-            <a:pPr indent="0" marL="0">
+            <a:pPr marL="0" indent="0">
               <a:lnSpc>
                 <a:spcPts val="1800"/>
               </a:lnSpc>
@@ -10400,7 +10614,7 @@
           <a:bodyPr wrap="square" lIns="0" tIns="0" rIns="0" bIns="0" rtlCol="0" anchor="ctr"/>
           <a:lstStyle/>
           <a:p>
-            <a:pPr indent="0" marL="0">
+            <a:pPr marL="0" indent="0">
               <a:lnSpc>
                 <a:spcPts val="1500"/>
               </a:lnSpc>
@@ -10442,7 +10656,7 @@
           <a:bodyPr wrap="square" lIns="0" tIns="0" rIns="0" bIns="0" rtlCol="0" anchor="ctr"/>
           <a:lstStyle/>
           <a:p>
-            <a:pPr indent="0" marL="0">
+            <a:pPr marL="0" indent="0">
               <a:buNone/>
             </a:pPr>
             <a:r>
@@ -10486,6 +10700,13 @@
             <a:prstDash val="solid"/>
           </a:ln>
         </p:spPr>
+        <p:txBody>
+          <a:bodyPr/>
+          <a:lstStyle/>
+          <a:p>
+            <a:endParaRPr lang="en-US"/>
+          </a:p>
+        </p:txBody>
       </p:sp>
       <p:sp>
         <p:nvSpPr>
@@ -10506,6 +10727,13 @@
           </a:solidFill>
           <a:ln/>
         </p:spPr>
+        <p:txBody>
+          <a:bodyPr/>
+          <a:lstStyle/>
+          <a:p>
+            <a:endParaRPr lang="en-US"/>
+          </a:p>
+        </p:txBody>
       </p:sp>
       <p:sp>
         <p:nvSpPr>
@@ -10528,7 +10756,7 @@
           <a:bodyPr wrap="square" lIns="0" tIns="0" rIns="0" bIns="0" rtlCol="0" anchor="ctr"/>
           <a:lstStyle/>
           <a:p>
-            <a:pPr algn="ctr" indent="0" marL="0">
+            <a:pPr marL="0" indent="0" algn="ctr">
               <a:buNone/>
             </a:pPr>
             <a:r>
@@ -10567,7 +10795,7 @@
           <a:bodyPr wrap="square" lIns="0" tIns="0" rIns="0" bIns="0" rtlCol="0" anchor="ctr"/>
           <a:lstStyle/>
           <a:p>
-            <a:pPr indent="0" marL="0">
+            <a:pPr marL="0" indent="0">
               <a:lnSpc>
                 <a:spcPts val="1800"/>
               </a:lnSpc>
@@ -10609,7 +10837,7 @@
           <a:bodyPr wrap="square" lIns="0" tIns="0" rIns="0" bIns="0" rtlCol="0" anchor="ctr"/>
           <a:lstStyle/>
           <a:p>
-            <a:pPr indent="0" marL="0">
+            <a:pPr marL="0" indent="0">
               <a:lnSpc>
                 <a:spcPts val="1500"/>
               </a:lnSpc>
@@ -10651,7 +10879,7 @@
           <a:bodyPr wrap="square" lIns="0" tIns="0" rIns="0" bIns="0" rtlCol="0" anchor="ctr"/>
           <a:lstStyle/>
           <a:p>
-            <a:pPr indent="0" marL="0">
+            <a:pPr marL="0" indent="0">
               <a:buNone/>
             </a:pPr>
             <a:r>
@@ -10695,6 +10923,13 @@
             <a:prstDash val="solid"/>
           </a:ln>
         </p:spPr>
+        <p:txBody>
+          <a:bodyPr/>
+          <a:lstStyle/>
+          <a:p>
+            <a:endParaRPr lang="en-US"/>
+          </a:p>
+        </p:txBody>
       </p:sp>
       <p:sp>
         <p:nvSpPr>
@@ -10715,6 +10950,13 @@
           </a:solidFill>
           <a:ln/>
         </p:spPr>
+        <p:txBody>
+          <a:bodyPr/>
+          <a:lstStyle/>
+          <a:p>
+            <a:endParaRPr lang="en-US"/>
+          </a:p>
+        </p:txBody>
       </p:sp>
       <p:sp>
         <p:nvSpPr>
@@ -10737,7 +10979,7 @@
           <a:bodyPr wrap="square" lIns="0" tIns="0" rIns="0" bIns="0" rtlCol="0" anchor="ctr"/>
           <a:lstStyle/>
           <a:p>
-            <a:pPr algn="ctr" indent="0" marL="0">
+            <a:pPr marL="0" indent="0" algn="ctr">
               <a:buNone/>
             </a:pPr>
             <a:r>
@@ -10776,7 +11018,7 @@
           <a:bodyPr wrap="square" lIns="0" tIns="0" rIns="0" bIns="0" rtlCol="0" anchor="ctr"/>
           <a:lstStyle/>
           <a:p>
-            <a:pPr indent="0" marL="0">
+            <a:pPr marL="0" indent="0">
               <a:lnSpc>
                 <a:spcPts val="1800"/>
               </a:lnSpc>
@@ -10818,7 +11060,7 @@
           <a:bodyPr wrap="square" lIns="0" tIns="0" rIns="0" bIns="0" rtlCol="0" anchor="ctr"/>
           <a:lstStyle/>
           <a:p>
-            <a:pPr indent="0" marL="0">
+            <a:pPr marL="0" indent="0">
               <a:lnSpc>
                 <a:spcPts val="1500"/>
               </a:lnSpc>
@@ -10860,7 +11102,7 @@
           <a:bodyPr wrap="square" lIns="0" tIns="0" rIns="0" bIns="0" rtlCol="0" anchor="ctr"/>
           <a:lstStyle/>
           <a:p>
-            <a:pPr indent="0" marL="0">
+            <a:pPr marL="0" indent="0">
               <a:buNone/>
             </a:pPr>
             <a:r>
@@ -10904,6 +11146,13 @@
             <a:prstDash val="solid"/>
           </a:ln>
         </p:spPr>
+        <p:txBody>
+          <a:bodyPr/>
+          <a:lstStyle/>
+          <a:p>
+            <a:endParaRPr lang="en-US"/>
+          </a:p>
+        </p:txBody>
       </p:sp>
       <p:sp>
         <p:nvSpPr>
@@ -10924,6 +11173,13 @@
           </a:solidFill>
           <a:ln/>
         </p:spPr>
+        <p:txBody>
+          <a:bodyPr/>
+          <a:lstStyle/>
+          <a:p>
+            <a:endParaRPr lang="en-US"/>
+          </a:p>
+        </p:txBody>
       </p:sp>
       <p:sp>
         <p:nvSpPr>
@@ -10946,7 +11202,7 @@
           <a:bodyPr wrap="square" lIns="0" tIns="0" rIns="0" bIns="0" rtlCol="0" anchor="ctr"/>
           <a:lstStyle/>
           <a:p>
-            <a:pPr algn="ctr" indent="0" marL="0">
+            <a:pPr marL="0" indent="0" algn="ctr">
               <a:buNone/>
             </a:pPr>
             <a:r>
@@ -10985,7 +11241,7 @@
           <a:bodyPr wrap="square" lIns="0" tIns="0" rIns="0" bIns="0" rtlCol="0" anchor="ctr"/>
           <a:lstStyle/>
           <a:p>
-            <a:pPr indent="0" marL="0">
+            <a:pPr marL="0" indent="0">
               <a:lnSpc>
                 <a:spcPts val="1800"/>
               </a:lnSpc>
@@ -11027,7 +11283,7 @@
           <a:bodyPr wrap="square" lIns="0" tIns="0" rIns="0" bIns="0" rtlCol="0" anchor="ctr"/>
           <a:lstStyle/>
           <a:p>
-            <a:pPr indent="0" marL="0">
+            <a:pPr marL="0" indent="0">
               <a:lnSpc>
                 <a:spcPts val="1500"/>
               </a:lnSpc>
@@ -11069,7 +11325,7 @@
           <a:bodyPr wrap="square" lIns="0" tIns="0" rIns="0" bIns="0" rtlCol="0" anchor="ctr"/>
           <a:lstStyle/>
           <a:p>
-            <a:pPr indent="0" marL="0">
+            <a:pPr marL="0" indent="0">
               <a:buNone/>
             </a:pPr>
             <a:r>
@@ -11108,7 +11364,7 @@
           <a:bodyPr wrap="square" lIns="0" tIns="0" rIns="0" bIns="0" rtlCol="0" anchor="ctr"/>
           <a:lstStyle/>
           <a:p>
-            <a:pPr indent="0" marL="0">
+            <a:pPr marL="0" indent="0">
               <a:buNone/>
             </a:pPr>
             <a:r>
@@ -11427,4 +11683,319 @@
     </a:ext>
   </a:extLst>
 </a:theme>
+</file>
+
+<file path=ppt/theme/theme2.xml><?xml version="1.0" encoding="utf-8"?>
+<a:theme xmlns:a="http://schemas.openxmlformats.org/drawingml/2006/main" name="Office Theme">
+  <a:themeElements>
+    <a:clrScheme name="Office">
+      <a:dk1>
+        <a:sysClr val="windowText" lastClr="000000"/>
+      </a:dk1>
+      <a:lt1>
+        <a:sysClr val="window" lastClr="FFFFFF"/>
+      </a:lt1>
+      <a:dk2>
+        <a:srgbClr val="0E2841"/>
+      </a:dk2>
+      <a:lt2>
+        <a:srgbClr val="E8E8E8"/>
+      </a:lt2>
+      <a:accent1>
+        <a:srgbClr val="156082"/>
+      </a:accent1>
+      <a:accent2>
+        <a:srgbClr val="E97132"/>
+      </a:accent2>
+      <a:accent3>
+        <a:srgbClr val="196B24"/>
+      </a:accent3>
+      <a:accent4>
+        <a:srgbClr val="0F9ED5"/>
+      </a:accent4>
+      <a:accent5>
+        <a:srgbClr val="A02B93"/>
+      </a:accent5>
+      <a:accent6>
+        <a:srgbClr val="4EA72E"/>
+      </a:accent6>
+      <a:hlink>
+        <a:srgbClr val="467886"/>
+      </a:hlink>
+      <a:folHlink>
+        <a:srgbClr val="96607D"/>
+      </a:folHlink>
+    </a:clrScheme>
+    <a:fontScheme name="Office">
+      <a:majorFont>
+        <a:latin typeface="Aptos Display" panose="02110004020202020204"/>
+        <a:ea typeface=""/>
+        <a:cs typeface=""/>
+        <a:font script="Jpan" typeface="游ゴシック Light"/>
+        <a:font script="Hang" typeface="맑은 고딕"/>
+        <a:font script="Hans" typeface="等线 Light"/>
+        <a:font script="Hant" typeface="新細明體"/>
+        <a:font script="Arab" typeface="Times New Roman"/>
+        <a:font script="Hebr" typeface="Times New Roman"/>
+        <a:font script="Thai" typeface="Angsana New"/>
+        <a:font script="Ethi" typeface="Nyala"/>
+        <a:font script="Beng" typeface="Vrinda"/>
+        <a:font script="Gujr" typeface="Shruti"/>
+        <a:font script="Khmr" typeface="MoolBoran"/>
+        <a:font script="Knda" typeface="Tunga"/>
+        <a:font script="Guru" typeface="Raavi"/>
+        <a:font script="Cans" typeface="Euphemia"/>
+        <a:font script="Cher" typeface="Plantagenet Cherokee"/>
+        <a:font script="Yiii" typeface="Microsoft Yi Baiti"/>
+        <a:font script="Tibt" typeface="Microsoft Himalaya"/>
+        <a:font script="Thaa" typeface="MV Boli"/>
+        <a:font script="Deva" typeface="Mangal"/>
+        <a:font script="Telu" typeface="Gautami"/>
+        <a:font script="Taml" typeface="Latha"/>
+        <a:font script="Syrc" typeface="Estrangelo Edessa"/>
+        <a:font script="Orya" typeface="Kalinga"/>
+        <a:font script="Mlym" typeface="Kartika"/>
+        <a:font script="Laoo" typeface="DokChampa"/>
+        <a:font script="Sinh" typeface="Iskoola Pota"/>
+        <a:font script="Mong" typeface="Mongolian Baiti"/>
+        <a:font script="Viet" typeface="Times New Roman"/>
+        <a:font script="Uigh" typeface="Microsoft Uighur"/>
+        <a:font script="Geor" typeface="Sylfaen"/>
+        <a:font script="Armn" typeface="Arial"/>
+        <a:font script="Bugi" typeface="Leelawadee UI"/>
+        <a:font script="Bopo" typeface="Microsoft JhengHei"/>
+        <a:font script="Java" typeface="Javanese Text"/>
+        <a:font script="Lisu" typeface="Segoe UI"/>
+        <a:font script="Mymr" typeface="Myanmar Text"/>
+        <a:font script="Nkoo" typeface="Ebrima"/>
+        <a:font script="Olck" typeface="Nirmala UI"/>
+        <a:font script="Osma" typeface="Ebrima"/>
+        <a:font script="Phag" typeface="Phagspa"/>
+        <a:font script="Syrn" typeface="Estrangelo Edessa"/>
+        <a:font script="Syrj" typeface="Estrangelo Edessa"/>
+        <a:font script="Syre" typeface="Estrangelo Edessa"/>
+        <a:font script="Sora" typeface="Nirmala UI"/>
+        <a:font script="Tale" typeface="Microsoft Tai Le"/>
+        <a:font script="Talu" typeface="Microsoft New Tai Lue"/>
+        <a:font script="Tfng" typeface="Ebrima"/>
+      </a:majorFont>
+      <a:minorFont>
+        <a:latin typeface="Aptos" panose="02110004020202020204"/>
+        <a:ea typeface=""/>
+        <a:cs typeface=""/>
+        <a:font script="Jpan" typeface="游ゴシック"/>
+        <a:font script="Hang" typeface="맑은 고딕"/>
+        <a:font script="Hans" typeface="等线"/>
+        <a:font script="Hant" typeface="新細明體"/>
+        <a:font script="Arab" typeface="Arial"/>
+        <a:font script="Hebr" typeface="Arial"/>
+        <a:font script="Thai" typeface="Cordia New"/>
+        <a:font script="Ethi" typeface="Nyala"/>
+        <a:font script="Beng" typeface="Vrinda"/>
+        <a:font script="Gujr" typeface="Shruti"/>
+        <a:font script="Khmr" typeface="DaunPenh"/>
+        <a:font script="Knda" typeface="Tunga"/>
+        <a:font script="Guru" typeface="Raavi"/>
+        <a:font script="Cans" typeface="Euphemia"/>
+        <a:font script="Cher" typeface="Plantagenet Cherokee"/>
+        <a:font script="Yiii" typeface="Microsoft Yi Baiti"/>
+        <a:font script="Tibt" typeface="Microsoft Himalaya"/>
+        <a:font script="Thaa" typeface="MV Boli"/>
+        <a:font script="Deva" typeface="Mangal"/>
+        <a:font script="Telu" typeface="Gautami"/>
+        <a:font script="Taml" typeface="Latha"/>
+        <a:font script="Syrc" typeface="Estrangelo Edessa"/>
+        <a:font script="Orya" typeface="Kalinga"/>
+        <a:font script="Mlym" typeface="Kartika"/>
+        <a:font script="Laoo" typeface="DokChampa"/>
+        <a:font script="Sinh" typeface="Iskoola Pota"/>
+        <a:font script="Mong" typeface="Mongolian Baiti"/>
+        <a:font script="Viet" typeface="Arial"/>
+        <a:font script="Uigh" typeface="Microsoft Uighur"/>
+        <a:font script="Geor" typeface="Sylfaen"/>
+        <a:font script="Armn" typeface="Arial"/>
+        <a:font script="Bugi" typeface="Leelawadee UI"/>
+        <a:font script="Bopo" typeface="Microsoft JhengHei"/>
+        <a:font script="Java" typeface="Javanese Text"/>
+        <a:font script="Lisu" typeface="Segoe UI"/>
+        <a:font script="Mymr" typeface="Myanmar Text"/>
+        <a:font script="Nkoo" typeface="Ebrima"/>
+        <a:font script="Olck" typeface="Nirmala UI"/>
+        <a:font script="Osma" typeface="Ebrima"/>
+        <a:font script="Phag" typeface="Phagspa"/>
+        <a:font script="Syrn" typeface="Estrangelo Edessa"/>
+        <a:font script="Syrj" typeface="Estrangelo Edessa"/>
+        <a:font script="Syre" typeface="Estrangelo Edessa"/>
+        <a:font script="Sora" typeface="Nirmala UI"/>
+        <a:font script="Tale" typeface="Microsoft Tai Le"/>
+        <a:font script="Talu" typeface="Microsoft New Tai Lue"/>
+        <a:font script="Tfng" typeface="Ebrima"/>
+      </a:minorFont>
+    </a:fontScheme>
+    <a:fmtScheme name="Office">
+      <a:fillStyleLst>
+        <a:solidFill>
+          <a:schemeClr val="phClr"/>
+        </a:solidFill>
+        <a:gradFill rotWithShape="1">
+          <a:gsLst>
+            <a:gs pos="0">
+              <a:schemeClr val="phClr">
+                <a:lumMod val="110000"/>
+                <a:satMod val="105000"/>
+                <a:tint val="67000"/>
+              </a:schemeClr>
+            </a:gs>
+            <a:gs pos="50000">
+              <a:schemeClr val="phClr">
+                <a:lumMod val="105000"/>
+                <a:satMod val="103000"/>
+                <a:tint val="73000"/>
+              </a:schemeClr>
+            </a:gs>
+            <a:gs pos="100000">
+              <a:schemeClr val="phClr">
+                <a:lumMod val="105000"/>
+                <a:satMod val="109000"/>
+                <a:tint val="81000"/>
+              </a:schemeClr>
+            </a:gs>
+          </a:gsLst>
+          <a:lin ang="5400000" scaled="0"/>
+        </a:gradFill>
+        <a:gradFill rotWithShape="1">
+          <a:gsLst>
+            <a:gs pos="0">
+              <a:schemeClr val="phClr">
+                <a:satMod val="103000"/>
+                <a:lumMod val="102000"/>
+                <a:tint val="94000"/>
+              </a:schemeClr>
+            </a:gs>
+            <a:gs pos="50000">
+              <a:schemeClr val="phClr">
+                <a:satMod val="110000"/>
+                <a:lumMod val="100000"/>
+                <a:shade val="100000"/>
+              </a:schemeClr>
+            </a:gs>
+            <a:gs pos="100000">
+              <a:schemeClr val="phClr">
+                <a:lumMod val="99000"/>
+                <a:satMod val="120000"/>
+                <a:shade val="78000"/>
+              </a:schemeClr>
+            </a:gs>
+          </a:gsLst>
+          <a:lin ang="5400000" scaled="0"/>
+        </a:gradFill>
+      </a:fillStyleLst>
+      <a:lnStyleLst>
+        <a:ln w="12700" cap="flat" cmpd="sng" algn="ctr">
+          <a:solidFill>
+            <a:schemeClr val="phClr"/>
+          </a:solidFill>
+          <a:prstDash val="solid"/>
+          <a:miter lim="800000"/>
+        </a:ln>
+        <a:ln w="19050" cap="flat" cmpd="sng" algn="ctr">
+          <a:solidFill>
+            <a:schemeClr val="phClr"/>
+          </a:solidFill>
+          <a:prstDash val="solid"/>
+          <a:miter lim="800000"/>
+        </a:ln>
+        <a:ln w="25400" cap="flat" cmpd="sng" algn="ctr">
+          <a:solidFill>
+            <a:schemeClr val="phClr"/>
+          </a:solidFill>
+          <a:prstDash val="solid"/>
+          <a:miter lim="800000"/>
+        </a:ln>
+      </a:lnStyleLst>
+      <a:effectStyleLst>
+        <a:effectStyle>
+          <a:effectLst/>
+        </a:effectStyle>
+        <a:effectStyle>
+          <a:effectLst/>
+        </a:effectStyle>
+        <a:effectStyle>
+          <a:effectLst>
+            <a:outerShdw blurRad="57150" dist="19050" dir="5400000" algn="ctr" rotWithShape="0">
+              <a:srgbClr val="000000">
+                <a:alpha val="63000"/>
+              </a:srgbClr>
+            </a:outerShdw>
+          </a:effectLst>
+        </a:effectStyle>
+      </a:effectStyleLst>
+      <a:bgFillStyleLst>
+        <a:solidFill>
+          <a:schemeClr val="phClr"/>
+        </a:solidFill>
+        <a:solidFill>
+          <a:schemeClr val="phClr">
+            <a:tint val="95000"/>
+            <a:satMod val="170000"/>
+          </a:schemeClr>
+        </a:solidFill>
+        <a:gradFill rotWithShape="1">
+          <a:gsLst>
+            <a:gs pos="0">
+              <a:schemeClr val="phClr">
+                <a:tint val="93000"/>
+                <a:satMod val="150000"/>
+                <a:shade val="98000"/>
+                <a:lumMod val="102000"/>
+              </a:schemeClr>
+            </a:gs>
+            <a:gs pos="50000">
+              <a:schemeClr val="phClr">
+                <a:tint val="98000"/>
+                <a:satMod val="130000"/>
+                <a:shade val="90000"/>
+                <a:lumMod val="103000"/>
+              </a:schemeClr>
+            </a:gs>
+            <a:gs pos="100000">
+              <a:schemeClr val="phClr">
+                <a:shade val="63000"/>
+                <a:satMod val="120000"/>
+              </a:schemeClr>
+            </a:gs>
+          </a:gsLst>
+          <a:lin ang="5400000" scaled="0"/>
+        </a:gradFill>
+      </a:bgFillStyleLst>
+    </a:fmtScheme>
+  </a:themeElements>
+  <a:objectDefaults>
+    <a:lnDef>
+      <a:spPr/>
+      <a:bodyPr/>
+      <a:lstStyle/>
+      <a:style>
+        <a:lnRef idx="2">
+          <a:schemeClr val="accent1"/>
+        </a:lnRef>
+        <a:fillRef idx="0">
+          <a:schemeClr val="accent1"/>
+        </a:fillRef>
+        <a:effectRef idx="1">
+          <a:schemeClr val="accent1"/>
+        </a:effectRef>
+        <a:fontRef idx="minor">
+          <a:schemeClr val="tx1"/>
+        </a:fontRef>
+      </a:style>
+    </a:lnDef>
+  </a:objectDefaults>
+  <a:extraClrSchemeLst/>
+  <a:extLst>
+    <a:ext uri="{05A4C25C-085E-4340-85A3-A5531E510DB2}">
+      <thm15:themeFamily xmlns:thm15="http://schemas.microsoft.com/office/thememl/2012/main" name="Office Theme" id="{2E142A2C-CD16-42D6-873A-C26D2A0506FA}" vid="{1BDDFF52-6CD6-40A5-AB3C-68EB2F1E4D0A}"/>
+    </a:ext>
+  </a:extLst>
+</a:theme>
 </file>
</xml_diff>